<commit_message>
J2312 deck: add cross-match summary slide
Co-Authored-By: Claude Opus 5.5 <noreply@anthropic.com>
Claude-Session: https://claude.ai/code/session_01Cmkate8GQQC1zZ9rTMPdve
</commit_message>
<xml_diff>
--- a/outputs/j2312_deck/J2312_research.pptx
+++ b/outputs/j2312_deck/J2312_research.pptx
@@ -14,9 +14,10 @@
     <p:sldId id="262" r:id="rId8"/>
     <p:sldId id="263" r:id="rId9"/>
     <p:sldId id="264" r:id="rId10"/>
+    <p:sldId id="265" r:id="rId11"/>
   </p:sldIdLst>
   <p:notesMasterIdLst>
-    <p:notesMasterId r:id="rId11"/>
+    <p:notesMasterId r:id="rId12"/>
   </p:notesMasterIdLst>
   <p:sldSz cx="9144000" cy="5143500"/>
   <p:notesSz cx="5143500" cy="9144000"/>
@@ -115,29 +116,30 @@
   <p:extLst>
     <p:ext uri="{521415D9-36F7-43E2-AB2F-B90AF26B5E84}">
       <p14:sectionLst xmlns:p14="http://schemas.microsoft.com/office/powerpoint/2010/main">
-        <p14:section name="Overview" id="{366a1ea7-b212-a758-62d6-28b881e062f2}">
+        <p14:section name="Overview" id="{2aa413ef-0f02-1ce3-fae8-de98450e969f}">
           <p14:sldIdLst>
             <p14:sldId id="256"/>
             <p14:sldId id="257"/>
+            <p14:sldId id="258"/>
           </p14:sldIdLst>
         </p14:section>
-        <p14:section name="Binary" id="{9204871b-38aa-c2fc-0f2e-7db83bbef9f9}">
+        <p14:section name="Binary" id="{d65b7279-d9b7-48f2-eb58-f48821ff2a0c}">
           <p14:sldIdLst>
-            <p14:sldId id="258"/>
             <p14:sldId id="259"/>
+            <p14:sldId id="260"/>
           </p14:sldIdLst>
         </p14:section>
-        <p14:section name="Infrared excess" id="{e7576d89-f392-a032-f905-29eb4abe2db2}">
+        <p14:section name="Infrared excess" id="{60a34421-05f0-0723-9e5a-aa02fae68943}">
           <p14:sldIdLst>
-            <p14:sldId id="260"/>
             <p14:sldId id="261"/>
             <p14:sldId id="262"/>
             <p14:sldId id="263"/>
+            <p14:sldId id="264"/>
           </p14:sldIdLst>
         </p14:section>
-        <p14:section name="Next steps" id="{7490940d-81a4-803f-9482-02c5794136aa}">
+        <p14:section name="Next steps" id="{d6f7db1d-fbe4-0e67-0b6f-9bc7e087c9bb}">
           <p14:sldIdLst>
-            <p14:sldId id="264"/>
+            <p14:sldId id="265"/>
           </p14:sldIdLst>
         </p14:section>
       </p14:sectionLst>
@@ -568,6 +570,94 @@
             <a:fld id="{F7021451-1387-4CA6-816F-3879F97B5CBC}" type="slidenum">
               <a:rPr lang="en-US"/>
               <a:t>1</a:t>
+            </a:fld>
+            <a:endParaRPr lang="en-US"/>
+          </a:p>
+        </p:txBody>
+      </p:sp>
+    </p:spTree>
+    <p:extLst>
+      <p:ext uri="{BB962C8B-B14F-4D97-AF65-F5344CB8AC3E}">
+        <p14:creationId xmlns:p14="http://schemas.microsoft.com/office/powerpoint/2010/main" val="1024086991"/>
+      </p:ext>
+    </p:extLst>
+  </p:cSld>
+  <p:clrMapOvr>
+    <a:masterClrMapping/>
+  </p:clrMapOvr>
+</p:notes>
+</file>
+
+<file path=ppt/notesSlides/notesSlide10.xml><?xml version="1.0" encoding="utf-8"?>
+<p:notes xmlns:a="http://schemas.openxmlformats.org/drawingml/2006/main" xmlns:r="http://schemas.openxmlformats.org/officeDocument/2006/relationships" xmlns:p="http://schemas.openxmlformats.org/presentationml/2006/main">
+  <p:cSld>
+    <p:spTree>
+      <p:nvGrpSpPr>
+        <p:cNvPr id="1" name=""/>
+        <p:cNvGrpSpPr/>
+        <p:nvPr/>
+      </p:nvGrpSpPr>
+      <p:grpSpPr>
+        <a:xfrm>
+          <a:off x="0" y="0"/>
+          <a:ext cx="0" cy="0"/>
+          <a:chOff x="0" y="0"/>
+          <a:chExt cx="0" cy="0"/>
+        </a:xfrm>
+      </p:grpSpPr>
+      <p:sp>
+        <p:nvSpPr>
+          <p:cNvPr id="2" name="Slide Image Placeholder 1"/>
+          <p:cNvSpPr>
+            <a:spLocks noGrp="1" noRot="1" noChangeAspect="1"/>
+          </p:cNvSpPr>
+          <p:nvPr>
+            <p:ph type="sldImg"/>
+          </p:nvPr>
+        </p:nvSpPr>
+        <p:spPr/>
+      </p:sp>
+      <p:sp>
+        <p:nvSpPr>
+          <p:cNvPr id="3" name="Notes Placeholder 2"/>
+          <p:cNvSpPr>
+            <a:spLocks noGrp="1"/>
+          </p:cNvSpPr>
+          <p:nvPr>
+            <p:ph type="body" idx="1"/>
+          </p:nvPr>
+        </p:nvSpPr>
+        <p:spPr/>
+        <p:txBody>
+          <a:bodyPr/>
+          <a:lstStyle/>
+          <a:p>
+            <a:r>
+              <a:rPr lang="en-US" dirty="0"/>
+              <a:t/>
+            </a:r>
+            <a:endParaRPr lang="en-US" dirty="0"/>
+          </a:p>
+        </p:txBody>
+      </p:sp>
+      <p:sp>
+        <p:nvSpPr>
+          <p:cNvPr id="4" name="Slide Number Placeholder 3"/>
+          <p:cNvSpPr>
+            <a:spLocks noGrp="1"/>
+          </p:cNvSpPr>
+          <p:nvPr>
+            <p:ph type="sldNum" sz="quarter" idx="10"/>
+          </p:nvPr>
+        </p:nvSpPr>
+        <p:spPr/>
+        <p:txBody>
+          <a:bodyPr/>
+          <a:lstStyle/>
+          <a:p>
+            <a:fld id="{F7021451-1387-4CA6-816F-3879F97B5CBC}" type="slidenum">
+              <a:rPr lang="en-US"/>
+              <a:t>10</a:t>
             </a:fld>
             <a:endParaRPr lang="en-US"/>
           </a:p>
@@ -1980,6 +2070,121 @@
 </p:sld>
 </file>
 
+<file path=ppt/slides/slide10.xml><?xml version="1.0" encoding="utf-8"?>
+<p:sld xmlns:a="http://schemas.openxmlformats.org/drawingml/2006/main" xmlns:r="http://schemas.openxmlformats.org/officeDocument/2006/relationships" xmlns:p="http://schemas.openxmlformats.org/presentationml/2006/main">
+  <p:cSld name="Slide 10">
+    <p:spTree>
+      <p:nvGrpSpPr>
+        <p:cNvPr id="1" name=""/>
+        <p:cNvGrpSpPr/>
+        <p:nvPr/>
+      </p:nvGrpSpPr>
+      <p:grpSpPr>
+        <a:xfrm>
+          <a:off x="0" y="0"/>
+          <a:ext cx="0" cy="0"/>
+          <a:chOff x="0" y="0"/>
+          <a:chExt cx="0" cy="0"/>
+        </a:xfrm>
+      </p:grpSpPr>
+      <p:sp>
+        <p:nvSpPr>
+          <p:cNvPr id="2" name="Text 0"/>
+          <p:cNvSpPr/>
+          <p:nvPr>
+            <p:ph idx="100" type="title" hasCustomPrompt="1"/>
+          </p:nvPr>
+        </p:nvSpPr>
+        <p:spPr>
+          <a:xfrm>
+            <a:off x="548640" y="1371600"/>
+            <a:ext cx="8046720" cy="1371600"/>
+          </a:xfrm>
+          <a:prstGeom prst="rect">
+            <a:avLst/>
+          </a:prstGeom>
+          <a:noFill/>
+          <a:ln/>
+        </p:spPr>
+        <p:txBody>
+          <a:bodyPr wrap="square" rtlCol="0" anchor="b"/>
+          <a:lstStyle/>
+          <a:p>
+            <a:pPr indent="0" marL="0">
+              <a:buNone/>
+            </a:pPr>
+            <a:r>
+              <a:rPr lang="en-US" sz="3600" b="1" dirty="0">
+                <a:solidFill>
+                  <a:schemeClr val="bg1"/>
+                </a:solidFill>
+                <a:latin typeface="+mj-lt" pitchFamily="34" charset="0"/>
+                <a:ea typeface="+mj-lt" pitchFamily="34" charset="-122"/>
+                <a:cs typeface="+mj-lt" pitchFamily="34" charset="-120"/>
+              </a:rPr>
+              <a:t>Excess real, origin uncertain</a:t>
+            </a:r>
+            <a:endParaRPr lang="en-US" sz="3600" dirty="0"/>
+          </a:p>
+        </p:txBody>
+      </p:sp>
+      <p:sp>
+        <p:nvSpPr>
+          <p:cNvPr id="3" name="Text 0"/>
+          <p:cNvSpPr/>
+          <p:nvPr>
+            <p:ph idx="101" type="body" hasCustomPrompt="1"/>
+          </p:nvPr>
+        </p:nvSpPr>
+        <p:spPr>
+          <a:xfrm>
+            <a:off x="548640" y="2880360"/>
+            <a:ext cx="8046720" cy="1097280"/>
+          </a:xfrm>
+          <a:prstGeom prst="rect">
+            <a:avLst/>
+          </a:prstGeom>
+          <a:noFill/>
+          <a:ln/>
+        </p:spPr>
+        <p:txBody>
+          <a:bodyPr wrap="square" rtlCol="0" anchor="t"/>
+          <a:lstStyle/>
+          <a:p>
+            <a:pPr indent="0" marL="0">
+              <a:buNone/>
+            </a:pPr>
+            <a:r>
+              <a:rPr lang="en-US" sz="1600" b="1" dirty="0">
+                <a:solidFill>
+                  <a:schemeClr val="accent1"/>
+                </a:solidFill>
+              </a:rPr>
+              <a:t>Next: </a:t>
+            </a:r>
+            <a:pPr indent="0" marL="0">
+              <a:buNone/>
+            </a:pPr>
+            <a:r>
+              <a:rPr lang="en-US" sz="1600" dirty="0">
+                <a:solidFill>
+                  <a:schemeClr val="accent4"/>
+                </a:solidFill>
+              </a:rPr>
+              <a:t>excess vs aperture size; Spitzer 24 µm or Herschel images; per-sector light-curve fit.</a:t>
+            </a:r>
+            <a:endParaRPr lang="en-US" sz="1600" dirty="0"/>
+          </a:p>
+        </p:txBody>
+      </p:sp>
+    </p:spTree>
+  </p:cSld>
+  <p:clrMapOvr>
+    <a:masterClrMapping/>
+  </p:clrMapOvr>
+</p:sld>
+</file>
+
 <file path=ppt/slides/slide2.xml><?xml version="1.0" encoding="utf-8"?>
 <p:sld xmlns:a="http://schemas.openxmlformats.org/drawingml/2006/main" xmlns:r="http://schemas.openxmlformats.org/officeDocument/2006/relationships" xmlns:p="http://schemas.openxmlformats.org/presentationml/2006/main">
   <p:cSld name="Slide 2">
@@ -2032,7 +2237,7 @@
                 <a:ea typeface="+mj-lt" pitchFamily="34" charset="-122"/>
                 <a:cs typeface="+mj-lt" pitchFamily="34" charset="-120"/>
               </a:rPr>
-              <a:t>Summary</a:t>
+              <a:t>How we found it: Disk Detective × eclipsing-binary cross-match</a:t>
             </a:r>
             <a:endParaRPr lang="en-US" sz="2200" dirty="0"/>
           </a:p>
@@ -2046,12 +2251,12 @@
         </p:nvSpPr>
         <p:spPr>
           <a:xfrm>
-            <a:off x="457200" y="1234440"/>
-            <a:ext cx="2606040" cy="1600200"/>
+            <a:off x="457200" y="1463040"/>
+            <a:ext cx="1874520" cy="1920240"/>
           </a:xfrm>
           <a:prstGeom prst="roundRect">
             <a:avLst>
-              <a:gd name="adj" fmla="val 4571"/>
+              <a:gd name="adj" fmla="val 3902"/>
             </a:avLst>
           </a:prstGeom>
           <a:solidFill>
@@ -2073,8 +2278,8 @@
         </p:nvSpPr>
         <p:spPr>
           <a:xfrm>
-            <a:off x="594360" y="1344168"/>
-            <a:ext cx="2331720" cy="685800"/>
+            <a:off x="594360" y="1572768"/>
+            <a:ext cx="1600200" cy="685800"/>
           </a:xfrm>
           <a:prstGeom prst="rect">
             <a:avLst/>
@@ -2098,7 +2303,7 @@
                 <a:ea typeface="+mj-lt" pitchFamily="34" charset="-122"/>
                 <a:cs typeface="+mj-lt" pitchFamily="34" charset="-120"/>
               </a:rPr>
-              <a:t>6.85 d</a:t>
+              <a:t>412,729</a:t>
             </a:r>
             <a:endParaRPr lang="en-US" sz="3000" dirty="0"/>
           </a:p>
@@ -2112,8 +2317,8 @@
         </p:nvSpPr>
         <p:spPr>
           <a:xfrm>
-            <a:off x="594360" y="2057400"/>
-            <a:ext cx="2331720" cy="685800"/>
+            <a:off x="594360" y="2286000"/>
+            <a:ext cx="1600200" cy="1005840"/>
           </a:xfrm>
           <a:prstGeom prst="rect">
             <a:avLst/>
@@ -2134,7 +2339,7 @@
                   <a:schemeClr val="tx1"/>
                 </a:solidFill>
               </a:rPr>
-              <a:t>Detached eclipsing binary of two ~9,900 K stars</a:t>
+              <a:t>Disk Detective 1.0 objects</a:t>
             </a:r>
             <a:endParaRPr lang="en-US" sz="1200" dirty="0"/>
           </a:p>
@@ -2142,18 +2347,54 @@
       </p:sp>
       <p:sp>
         <p:nvSpPr>
-          <p:cNvPr id="6" name="card"/>
+          <p:cNvPr id="6" name="Text 4"/>
+          <p:cNvSpPr txBox="1"/>
+          <p:nvPr/>
+        </p:nvSpPr>
+        <p:spPr>
+          <a:xfrm>
+            <a:off x="2331720" y="2103120"/>
+            <a:ext cx="228600" cy="457200"/>
+          </a:xfrm>
+          <a:prstGeom prst="rect">
+            <a:avLst/>
+          </a:prstGeom>
+          <a:noFill/>
+          <a:ln/>
+        </p:spPr>
+        <p:txBody>
+          <a:bodyPr wrap="square" lIns="0" tIns="0" rIns="0" bIns="0" rtlCol="0" anchor="ctr"/>
+          <a:lstStyle/>
+          <a:p>
+            <a:pPr algn="ctr" indent="0" marL="0">
+              <a:buNone/>
+            </a:pPr>
+            <a:r>
+              <a:rPr lang="en-US" sz="2000" b="1" dirty="0">
+                <a:solidFill>
+                  <a:schemeClr val="accent2"/>
+                </a:solidFill>
+              </a:rPr>
+              <a:t>→</a:t>
+            </a:r>
+            <a:endParaRPr lang="en-US" sz="2000" dirty="0"/>
+          </a:p>
+        </p:txBody>
+      </p:sp>
+      <p:sp>
+        <p:nvSpPr>
+          <p:cNvPr id="7" name="card"/>
           <p:cNvSpPr/>
           <p:nvPr/>
         </p:nvSpPr>
         <p:spPr>
           <a:xfrm>
-            <a:off x="3268980" y="1234440"/>
-            <a:ext cx="2606040" cy="1600200"/>
+            <a:off x="2560320" y="1463040"/>
+            <a:ext cx="1874520" cy="1920240"/>
           </a:xfrm>
           <a:prstGeom prst="roundRect">
             <a:avLst>
-              <a:gd name="adj" fmla="val 4571"/>
+              <a:gd name="adj" fmla="val 3902"/>
             </a:avLst>
           </a:prstGeom>
           <a:solidFill>
@@ -2169,14 +2410,14 @@
       </p:sp>
       <p:sp>
         <p:nvSpPr>
-          <p:cNvPr id="7" name="Text 5"/>
+          <p:cNvPr id="8" name="Text 6"/>
           <p:cNvSpPr txBox="1"/>
           <p:nvPr/>
         </p:nvSpPr>
         <p:spPr>
           <a:xfrm>
-            <a:off x="3406140" y="1344168"/>
-            <a:ext cx="2331720" cy="685800"/>
+            <a:off x="2697480" y="1572768"/>
+            <a:ext cx="1600200" cy="685800"/>
           </a:xfrm>
           <a:prstGeom prst="rect">
             <a:avLst/>
@@ -2200,7 +2441,7 @@
                 <a:ea typeface="+mj-lt" pitchFamily="34" charset="-122"/>
                 <a:cs typeface="+mj-lt" pitchFamily="34" charset="-120"/>
               </a:rPr>
-              <a:t>χ²ᵣ 0.39</a:t>
+              <a:t>800</a:t>
             </a:r>
             <a:endParaRPr lang="en-US" sz="3000" dirty="0"/>
           </a:p>
@@ -2208,14 +2449,14 @@
       </p:sp>
       <p:sp>
         <p:nvSpPr>
-          <p:cNvPr id="8" name="Text 6"/>
+          <p:cNvPr id="9" name="Text 7"/>
           <p:cNvSpPr txBox="1"/>
           <p:nvPr/>
         </p:nvSpPr>
         <p:spPr>
           <a:xfrm>
-            <a:off x="3406140" y="2057400"/>
-            <a:ext cx="2331720" cy="685800"/>
+            <a:off x="2697480" y="2286000"/>
+            <a:ext cx="1600200" cy="1005840"/>
           </a:xfrm>
           <a:prstGeom prst="rect">
             <a:avLst/>
@@ -2236,7 +2477,7 @@
                   <a:schemeClr val="tx1"/>
                 </a:solidFill>
               </a:rPr>
-              <a:t>PHOEBE binary model fits the TESS light curve</a:t>
+              <a:t>Matched to 15 eclipsing-binary catalogues within 3″</a:t>
             </a:r>
             <a:endParaRPr lang="en-US" sz="1200" dirty="0"/>
           </a:p>
@@ -2244,18 +2485,54 @@
       </p:sp>
       <p:sp>
         <p:nvSpPr>
-          <p:cNvPr id="9" name="card"/>
+          <p:cNvPr id="10" name="Text 8"/>
+          <p:cNvSpPr txBox="1"/>
+          <p:nvPr/>
+        </p:nvSpPr>
+        <p:spPr>
+          <a:xfrm>
+            <a:off x="4434840" y="2103120"/>
+            <a:ext cx="228600" cy="457200"/>
+          </a:xfrm>
+          <a:prstGeom prst="rect">
+            <a:avLst/>
+          </a:prstGeom>
+          <a:noFill/>
+          <a:ln/>
+        </p:spPr>
+        <p:txBody>
+          <a:bodyPr wrap="square" lIns="0" tIns="0" rIns="0" bIns="0" rtlCol="0" anchor="ctr"/>
+          <a:lstStyle/>
+          <a:p>
+            <a:pPr algn="ctr" indent="0" marL="0">
+              <a:buNone/>
+            </a:pPr>
+            <a:r>
+              <a:rPr lang="en-US" sz="2000" b="1" dirty="0">
+                <a:solidFill>
+                  <a:schemeClr val="accent2"/>
+                </a:solidFill>
+              </a:rPr>
+              <a:t>→</a:t>
+            </a:r>
+            <a:endParaRPr lang="en-US" sz="2000" dirty="0"/>
+          </a:p>
+        </p:txBody>
+      </p:sp>
+      <p:sp>
+        <p:nvSpPr>
+          <p:cNvPr id="11" name="card"/>
           <p:cNvSpPr/>
           <p:nvPr/>
         </p:nvSpPr>
         <p:spPr>
           <a:xfrm>
-            <a:off x="6080760" y="1234440"/>
-            <a:ext cx="2606040" cy="1600200"/>
+            <a:off x="4663440" y="1463040"/>
+            <a:ext cx="1874520" cy="1920240"/>
           </a:xfrm>
           <a:prstGeom prst="roundRect">
             <a:avLst>
-              <a:gd name="adj" fmla="val 4571"/>
+              <a:gd name="adj" fmla="val 3902"/>
             </a:avLst>
           </a:prstGeom>
           <a:solidFill>
@@ -2271,14 +2548,14 @@
       </p:sp>
       <p:sp>
         <p:nvSpPr>
-          <p:cNvPr id="10" name="Text 8"/>
+          <p:cNvPr id="12" name="Text 10"/>
           <p:cNvSpPr txBox="1"/>
           <p:nvPr/>
         </p:nvSpPr>
         <p:spPr>
           <a:xfrm>
-            <a:off x="6217920" y="1344168"/>
-            <a:ext cx="2331720" cy="685800"/>
+            <a:off x="4800600" y="1572768"/>
+            <a:ext cx="1600200" cy="685800"/>
           </a:xfrm>
           <a:prstGeom prst="rect">
             <a:avLst/>
@@ -2296,13 +2573,13 @@
             <a:r>
               <a:rPr lang="en-US" sz="3000" b="1" dirty="0">
                 <a:solidFill>
-                  <a:schemeClr val="accent5"/>
+                  <a:schemeClr val="accent1"/>
                 </a:solidFill>
                 <a:latin typeface="+mj-lt" pitchFamily="34" charset="0"/>
                 <a:ea typeface="+mj-lt" pitchFamily="34" charset="-122"/>
                 <a:cs typeface="+mj-lt" pitchFamily="34" charset="-120"/>
               </a:rPr>
-              <a:t>12.6σ</a:t>
+              <a:t>12</a:t>
             </a:r>
             <a:endParaRPr lang="en-US" sz="3000" dirty="0"/>
           </a:p>
@@ -2310,14 +2587,14 @@
       </p:sp>
       <p:sp>
         <p:nvSpPr>
-          <p:cNvPr id="11" name="Text 9"/>
+          <p:cNvPr id="13" name="Text 11"/>
           <p:cNvSpPr txBox="1"/>
           <p:nvPr/>
         </p:nvSpPr>
         <p:spPr>
           <a:xfrm>
-            <a:off x="6217920" y="2057400"/>
-            <a:ext cx="2331720" cy="685800"/>
+            <a:off x="4800600" y="2286000"/>
+            <a:ext cx="1600200" cy="1005840"/>
           </a:xfrm>
           <a:prstGeom prst="rect">
             <a:avLst/>
@@ -2338,7 +2615,7 @@
                   <a:schemeClr val="tx1"/>
                 </a:solidFill>
               </a:rPr>
-              <a:t>22 µm (W4) excess above the binary</a:t>
+              <a:t>Tier A after 18 checks (IR excess, images, TESS)</a:t>
             </a:r>
             <a:endParaRPr lang="en-US" sz="1200" dirty="0"/>
           </a:p>
@@ -2346,14 +2623,14 @@
       </p:sp>
       <p:sp>
         <p:nvSpPr>
-          <p:cNvPr id="12" name="Text 10"/>
+          <p:cNvPr id="14" name="Text 12"/>
           <p:cNvSpPr txBox="1"/>
           <p:nvPr/>
         </p:nvSpPr>
         <p:spPr>
           <a:xfrm>
-            <a:off x="457200" y="3200400"/>
-            <a:ext cx="8229600" cy="914400"/>
+            <a:off x="6537960" y="2103120"/>
+            <a:ext cx="228600" cy="457200"/>
           </a:xfrm>
           <a:prstGeom prst="rect">
             <a:avLst/>
@@ -2362,21 +2639,159 @@
           <a:ln/>
         </p:spPr>
         <p:txBody>
-          <a:bodyPr wrap="square" lIns="0" tIns="0" rIns="0" bIns="0" rtlCol="0" anchor="t"/>
+          <a:bodyPr wrap="square" lIns="0" tIns="0" rIns="0" bIns="0" rtlCol="0" anchor="ctr"/>
+          <a:lstStyle/>
+          <a:p>
+            <a:pPr algn="ctr" indent="0" marL="0">
+              <a:buNone/>
+            </a:pPr>
+            <a:r>
+              <a:rPr lang="en-US" sz="2000" b="1" dirty="0">
+                <a:solidFill>
+                  <a:schemeClr val="accent2"/>
+                </a:solidFill>
+              </a:rPr>
+              <a:t>→</a:t>
+            </a:r>
+            <a:endParaRPr lang="en-US" sz="2000" dirty="0"/>
+          </a:p>
+        </p:txBody>
+      </p:sp>
+      <p:sp>
+        <p:nvSpPr>
+          <p:cNvPr id="15" name="card"/>
+          <p:cNvSpPr/>
+          <p:nvPr/>
+        </p:nvSpPr>
+        <p:spPr>
+          <a:xfrm>
+            <a:off x="6766560" y="1463040"/>
+            <a:ext cx="1874520" cy="1920240"/>
+          </a:xfrm>
+          <a:prstGeom prst="roundRect">
+            <a:avLst>
+              <a:gd name="adj" fmla="val 3902"/>
+            </a:avLst>
+          </a:prstGeom>
+          <a:solidFill>
+            <a:schemeClr val="bg1"/>
+          </a:solidFill>
+          <a:ln w="9525">
+            <a:solidFill>
+              <a:srgbClr val="C8CEDB"/>
+            </a:solidFill>
+            <a:prstDash val="solid"/>
+          </a:ln>
+        </p:spPr>
+      </p:sp>
+      <p:sp>
+        <p:nvSpPr>
+          <p:cNvPr id="16" name="Text 14"/>
+          <p:cNvSpPr txBox="1"/>
+          <p:nvPr/>
+        </p:nvSpPr>
+        <p:spPr>
+          <a:xfrm>
+            <a:off x="6903720" y="1572768"/>
+            <a:ext cx="1600200" cy="685800"/>
+          </a:xfrm>
+          <a:prstGeom prst="rect">
+            <a:avLst/>
+          </a:prstGeom>
+          <a:noFill/>
+          <a:ln/>
+        </p:spPr>
+        <p:txBody>
+          <a:bodyPr wrap="square" lIns="0" tIns="0" rIns="0" bIns="0" rtlCol="0" anchor="ctr"/>
           <a:lstStyle/>
           <a:p>
             <a:pPr indent="0" marL="0">
               <a:buNone/>
             </a:pPr>
             <a:r>
-              <a:rPr lang="en-US" sz="1600" dirty="0">
+              <a:rPr lang="en-US" sz="3000" b="1" dirty="0">
+                <a:solidFill>
+                  <a:schemeClr val="accent5"/>
+                </a:solidFill>
+                <a:latin typeface="+mj-lt" pitchFamily="34" charset="0"/>
+                <a:ea typeface="+mj-lt" pitchFamily="34" charset="-122"/>
+                <a:cs typeface="+mj-lt" pitchFamily="34" charset="-120"/>
+              </a:rPr>
+              <a:t>J2312</a:t>
+            </a:r>
+            <a:endParaRPr lang="en-US" sz="3000" dirty="0"/>
+          </a:p>
+        </p:txBody>
+      </p:sp>
+      <p:sp>
+        <p:nvSpPr>
+          <p:cNvPr id="17" name="Text 15"/>
+          <p:cNvSpPr txBox="1"/>
+          <p:nvPr/>
+        </p:nvSpPr>
+        <p:spPr>
+          <a:xfrm>
+            <a:off x="6903720" y="2286000"/>
+            <a:ext cx="1600200" cy="1005840"/>
+          </a:xfrm>
+          <a:prstGeom prst="rect">
+            <a:avLst/>
+          </a:prstGeom>
+          <a:noFill/>
+          <a:ln/>
+        </p:spPr>
+        <p:txBody>
+          <a:bodyPr wrap="square" lIns="0" tIns="0" rIns="0" bIns="0" rtlCol="0" anchor="t"/>
+          <a:lstStyle/>
+          <a:p>
+            <a:pPr indent="0" marL="0">
+              <a:buNone/>
+            </a:pPr>
+            <a:r>
+              <a:rPr lang="en-US" sz="1200" dirty="0">
                 <a:solidFill>
                   <a:schemeClr val="tx1"/>
                 </a:solidFill>
               </a:rPr>
-              <a:t>The excess is real and not from a neighbour, but the star sits on extended dust emission, so a disk is not yet proven.</a:t>
-            </a:r>
-            <a:endParaRPr lang="en-US" sz="1600" dirty="0"/>
+              <a:t>Tier A, passes all 18 checks</a:t>
+            </a:r>
+            <a:endParaRPr lang="en-US" sz="1200" dirty="0"/>
+          </a:p>
+        </p:txBody>
+      </p:sp>
+      <p:sp>
+        <p:nvSpPr>
+          <p:cNvPr id="18" name="Text 16"/>
+          <p:cNvSpPr txBox="1"/>
+          <p:nvPr/>
+        </p:nvSpPr>
+        <p:spPr>
+          <a:xfrm>
+            <a:off x="457200" y="3749040"/>
+            <a:ext cx="8229600" cy="457200"/>
+          </a:xfrm>
+          <a:prstGeom prst="rect">
+            <a:avLst/>
+          </a:prstGeom>
+          <a:noFill/>
+          <a:ln/>
+        </p:spPr>
+        <p:txBody>
+          <a:bodyPr wrap="square" lIns="0" tIns="0" rIns="0" bIns="0" rtlCol="0" anchor="ctr"/>
+          <a:lstStyle/>
+          <a:p>
+            <a:pPr indent="0" marL="0">
+              <a:buNone/>
+            </a:pPr>
+            <a:r>
+              <a:rPr lang="en-US" sz="1300" dirty="0">
+                <a:solidFill>
+                  <a:schemeClr val="tx1"/>
+                </a:solidFill>
+              </a:rPr>
+              <a:t>Catalogues include Gaia DR3, VSX, ZTF, ATLAS, ASAS-SN and the TESS EB lists.</a:t>
+            </a:r>
+            <a:endParaRPr lang="en-US" sz="1300" dirty="0"/>
           </a:p>
         </p:txBody>
       </p:sp>
@@ -2485,46 +2900,49 @@
                 <a:ea typeface="+mj-lt" pitchFamily="34" charset="-122"/>
                 <a:cs typeface="+mj-lt" pitchFamily="34" charset="-120"/>
               </a:rPr>
-              <a:t>Unequal eclipse depths fix the period at 6.85 d</a:t>
+              <a:t>Summary</a:t>
             </a:r>
             <a:endParaRPr lang="en-US" sz="2200" dirty="0"/>
           </a:p>
         </p:txBody>
       </p:sp>
-      <p:pic>
-        <p:nvPicPr>
-          <p:cNvPr id="3" name="Image 0" descr="/tmp/claude-0/-home-claude-tic-106588577-phoebe/9801b85f-ee4b-5050-ac26-be5ee36f67a6/scratchpad/deck/img/ecl.jpg">    </p:cNvPr>
-          <p:cNvPicPr>
-            <a:picLocks noChangeAspect="1"/>
-          </p:cNvPicPr>
+      <p:sp>
+        <p:nvSpPr>
+          <p:cNvPr id="3" name="card"/>
+          <p:cNvSpPr/>
           <p:nvPr/>
-        </p:nvPicPr>
-        <p:blipFill>
-          <a:blip r:embed="rId1"/>
-          <a:stretch>
-            <a:fillRect/>
-          </a:stretch>
-        </p:blipFill>
-        <p:spPr>
-          <a:xfrm>
-            <a:off x="457200" y="1188720"/>
-            <a:ext cx="5394960" cy="2779776"/>
-          </a:xfrm>
-          <a:prstGeom prst="rect">
-            <a:avLst/>
-          </a:prstGeom>
-        </p:spPr>
-      </p:pic>
-      <p:sp>
-        <p:nvSpPr>
-          <p:cNvPr id="4" name="Text 1"/>
+        </p:nvSpPr>
+        <p:spPr>
+          <a:xfrm>
+            <a:off x="457200" y="1234440"/>
+            <a:ext cx="2606040" cy="1600200"/>
+          </a:xfrm>
+          <a:prstGeom prst="roundRect">
+            <a:avLst>
+              <a:gd name="adj" fmla="val 4571"/>
+            </a:avLst>
+          </a:prstGeom>
+          <a:solidFill>
+            <a:schemeClr val="bg1"/>
+          </a:solidFill>
+          <a:ln w="9525">
+            <a:solidFill>
+              <a:srgbClr val="C8CEDB"/>
+            </a:solidFill>
+            <a:prstDash val="solid"/>
+          </a:ln>
+        </p:spPr>
+      </p:sp>
+      <p:sp>
+        <p:nvSpPr>
+          <p:cNvPr id="4" name="Text 2"/>
           <p:cNvSpPr txBox="1"/>
           <p:nvPr/>
         </p:nvSpPr>
         <p:spPr>
           <a:xfrm>
-            <a:off x="457200" y="4069080"/>
-            <a:ext cx="5394960" cy="274320"/>
+            <a:off x="594360" y="1344168"/>
+            <a:ext cx="2331720" cy="685800"/>
           </a:xfrm>
           <a:prstGeom prst="rect">
             <a:avLst/>
@@ -2540,27 +2958,30 @@
               <a:buNone/>
             </a:pPr>
             <a:r>
-              <a:rPr lang="en-US" sz="1000" i="1" dirty="0">
-                <a:solidFill>
-                  <a:schemeClr val="accent2"/>
-                </a:solidFill>
+              <a:rPr lang="en-US" sz="3000" b="1" dirty="0">
+                <a:solidFill>
+                  <a:schemeClr val="accent1"/>
+                </a:solidFill>
+                <a:latin typeface="+mj-lt" pitchFamily="34" charset="0"/>
+                <a:ea typeface="+mj-lt" pitchFamily="34" charset="-122"/>
+                <a:cs typeface="+mj-lt" pitchFamily="34" charset="-120"/>
               </a:rPr>
-              <a:t>Stacked eclipses in TESS sectors 16, 17 and 57. Blue = primary, red = secondary.</a:t>
-            </a:r>
-            <a:endParaRPr lang="en-US" sz="1000" dirty="0"/>
-          </a:p>
-        </p:txBody>
-      </p:sp>
-      <p:sp>
-        <p:nvSpPr>
-          <p:cNvPr id="5" name="Text 2"/>
+              <a:t>6.85 d</a:t>
+            </a:r>
+            <a:endParaRPr lang="en-US" sz="3000" dirty="0"/>
+          </a:p>
+        </p:txBody>
+      </p:sp>
+      <p:sp>
+        <p:nvSpPr>
+          <p:cNvPr id="5" name="Text 3"/>
           <p:cNvSpPr txBox="1"/>
           <p:nvPr/>
         </p:nvSpPr>
         <p:spPr>
           <a:xfrm>
-            <a:off x="6035040" y="1280160"/>
-            <a:ext cx="2651760" cy="2743200"/>
+            <a:off x="594360" y="2057400"/>
+            <a:ext cx="2331720" cy="685800"/>
           </a:xfrm>
           <a:prstGeom prst="rect">
             <a:avLst/>
@@ -2569,61 +2990,261 @@
           <a:ln/>
         </p:spPr>
         <p:txBody>
-          <a:bodyPr wrap="square" rtlCol="0" anchor="t"/>
-          <a:lstStyle/>
-          <a:p>
-            <a:pPr marL="342900" indent="-342900">
-              <a:spcAft>
-                <a:spcPts val="600"/>
-              </a:spcAft>
-              <a:buSzPct val="100000"/>
-              <a:buChar char="•"/>
+          <a:bodyPr wrap="square" lIns="0" tIns="0" rIns="0" bIns="0" rtlCol="0" anchor="t"/>
+          <a:lstStyle/>
+          <a:p>
+            <a:pPr indent="0" marL="0">
+              <a:buNone/>
             </a:pPr>
             <a:r>
-              <a:rPr lang="en-US" sz="1500" dirty="0">
+              <a:rPr lang="en-US" sz="1200" dirty="0">
                 <a:solidFill>
                   <a:schemeClr val="tx1"/>
                 </a:solidFill>
               </a:rPr>
-              <a:t>Primary is deeper than secondary (118σ)</a:t>
-            </a:r>
-            <a:endParaRPr lang="en-US" sz="1500" dirty="0"/>
-          </a:p>
-          <a:p>
-            <a:pPr marL="342900" indent="-342900">
-              <a:spcAft>
-                <a:spcPts val="600"/>
-              </a:spcAft>
-              <a:buSzPct val="100000"/>
-              <a:buChar char="•"/>
+              <a:t>Detached eclipsing binary of two ~9,900 K stars</a:t>
+            </a:r>
+            <a:endParaRPr lang="en-US" sz="1200" dirty="0"/>
+          </a:p>
+        </p:txBody>
+      </p:sp>
+      <p:sp>
+        <p:nvSpPr>
+          <p:cNvPr id="6" name="card"/>
+          <p:cNvSpPr/>
+          <p:nvPr/>
+        </p:nvSpPr>
+        <p:spPr>
+          <a:xfrm>
+            <a:off x="3268980" y="1234440"/>
+            <a:ext cx="2606040" cy="1600200"/>
+          </a:xfrm>
+          <a:prstGeom prst="roundRect">
+            <a:avLst>
+              <a:gd name="adj" fmla="val 4571"/>
+            </a:avLst>
+          </a:prstGeom>
+          <a:solidFill>
+            <a:schemeClr val="bg1"/>
+          </a:solidFill>
+          <a:ln w="9525">
+            <a:solidFill>
+              <a:srgbClr val="C8CEDB"/>
+            </a:solidFill>
+            <a:prstDash val="solid"/>
+          </a:ln>
+        </p:spPr>
+      </p:sp>
+      <p:sp>
+        <p:nvSpPr>
+          <p:cNvPr id="7" name="Text 5"/>
+          <p:cNvSpPr txBox="1"/>
+          <p:nvPr/>
+        </p:nvSpPr>
+        <p:spPr>
+          <a:xfrm>
+            <a:off x="3406140" y="1344168"/>
+            <a:ext cx="2331720" cy="685800"/>
+          </a:xfrm>
+          <a:prstGeom prst="rect">
+            <a:avLst/>
+          </a:prstGeom>
+          <a:noFill/>
+          <a:ln/>
+        </p:spPr>
+        <p:txBody>
+          <a:bodyPr wrap="square" lIns="0" tIns="0" rIns="0" bIns="0" rtlCol="0" anchor="ctr"/>
+          <a:lstStyle/>
+          <a:p>
+            <a:pPr indent="0" marL="0">
+              <a:buNone/>
             </a:pPr>
             <a:r>
-              <a:rPr lang="en-US" sz="1500" dirty="0">
+              <a:rPr lang="en-US" sz="3000" b="1" dirty="0">
+                <a:solidFill>
+                  <a:schemeClr val="accent1"/>
+                </a:solidFill>
+                <a:latin typeface="+mj-lt" pitchFamily="34" charset="0"/>
+                <a:ea typeface="+mj-lt" pitchFamily="34" charset="-122"/>
+                <a:cs typeface="+mj-lt" pitchFamily="34" charset="-120"/>
+              </a:rPr>
+              <a:t>χ²ᵣ 0.39</a:t>
+            </a:r>
+            <a:endParaRPr lang="en-US" sz="3000" dirty="0"/>
+          </a:p>
+        </p:txBody>
+      </p:sp>
+      <p:sp>
+        <p:nvSpPr>
+          <p:cNvPr id="8" name="Text 6"/>
+          <p:cNvSpPr txBox="1"/>
+          <p:nvPr/>
+        </p:nvSpPr>
+        <p:spPr>
+          <a:xfrm>
+            <a:off x="3406140" y="2057400"/>
+            <a:ext cx="2331720" cy="685800"/>
+          </a:xfrm>
+          <a:prstGeom prst="rect">
+            <a:avLst/>
+          </a:prstGeom>
+          <a:noFill/>
+          <a:ln/>
+        </p:spPr>
+        <p:txBody>
+          <a:bodyPr wrap="square" lIns="0" tIns="0" rIns="0" bIns="0" rtlCol="0" anchor="t"/>
+          <a:lstStyle/>
+          <a:p>
+            <a:pPr indent="0" marL="0">
+              <a:buNone/>
+            </a:pPr>
+            <a:r>
+              <a:rPr lang="en-US" sz="1200" dirty="0">
                 <a:solidFill>
                   <a:schemeClr val="tx1"/>
                 </a:solidFill>
               </a:rPr>
-              <a:t>Secondary is 16 min early: slight eccentricity</a:t>
-            </a:r>
-            <a:endParaRPr lang="en-US" sz="1500" dirty="0"/>
-          </a:p>
-          <a:p>
-            <a:pPr marL="342900" indent="-342900">
-              <a:spcAft>
-                <a:spcPts val="600"/>
-              </a:spcAft>
-              <a:buSzPct val="100000"/>
-              <a:buChar char="•"/>
+              <a:t>PHOEBE binary model fits the TESS light curve</a:t>
+            </a:r>
+            <a:endParaRPr lang="en-US" sz="1200" dirty="0"/>
+          </a:p>
+        </p:txBody>
+      </p:sp>
+      <p:sp>
+        <p:nvSpPr>
+          <p:cNvPr id="9" name="card"/>
+          <p:cNvSpPr/>
+          <p:nvPr/>
+        </p:nvSpPr>
+        <p:spPr>
+          <a:xfrm>
+            <a:off x="6080760" y="1234440"/>
+            <a:ext cx="2606040" cy="1600200"/>
+          </a:xfrm>
+          <a:prstGeom prst="roundRect">
+            <a:avLst>
+              <a:gd name="adj" fmla="val 4571"/>
+            </a:avLst>
+          </a:prstGeom>
+          <a:solidFill>
+            <a:schemeClr val="bg1"/>
+          </a:solidFill>
+          <a:ln w="9525">
+            <a:solidFill>
+              <a:srgbClr val="C8CEDB"/>
+            </a:solidFill>
+            <a:prstDash val="solid"/>
+          </a:ln>
+        </p:spPr>
+      </p:sp>
+      <p:sp>
+        <p:nvSpPr>
+          <p:cNvPr id="10" name="Text 8"/>
+          <p:cNvSpPr txBox="1"/>
+          <p:nvPr/>
+        </p:nvSpPr>
+        <p:spPr>
+          <a:xfrm>
+            <a:off x="6217920" y="1344168"/>
+            <a:ext cx="2331720" cy="685800"/>
+          </a:xfrm>
+          <a:prstGeom prst="rect">
+            <a:avLst/>
+          </a:prstGeom>
+          <a:noFill/>
+          <a:ln/>
+        </p:spPr>
+        <p:txBody>
+          <a:bodyPr wrap="square" lIns="0" tIns="0" rIns="0" bIns="0" rtlCol="0" anchor="ctr"/>
+          <a:lstStyle/>
+          <a:p>
+            <a:pPr indent="0" marL="0">
+              <a:buNone/>
             </a:pPr>
             <a:r>
-              <a:rPr lang="en-US" sz="1500" dirty="0">
+              <a:rPr lang="en-US" sz="3000" b="1" dirty="0">
+                <a:solidFill>
+                  <a:schemeClr val="accent5"/>
+                </a:solidFill>
+                <a:latin typeface="+mj-lt" pitchFamily="34" charset="0"/>
+                <a:ea typeface="+mj-lt" pitchFamily="34" charset="-122"/>
+                <a:cs typeface="+mj-lt" pitchFamily="34" charset="-120"/>
+              </a:rPr>
+              <a:t>12.6σ</a:t>
+            </a:r>
+            <a:endParaRPr lang="en-US" sz="3000" dirty="0"/>
+          </a:p>
+        </p:txBody>
+      </p:sp>
+      <p:sp>
+        <p:nvSpPr>
+          <p:cNvPr id="11" name="Text 9"/>
+          <p:cNvSpPr txBox="1"/>
+          <p:nvPr/>
+        </p:nvSpPr>
+        <p:spPr>
+          <a:xfrm>
+            <a:off x="6217920" y="2057400"/>
+            <a:ext cx="2331720" cy="685800"/>
+          </a:xfrm>
+          <a:prstGeom prst="rect">
+            <a:avLst/>
+          </a:prstGeom>
+          <a:noFill/>
+          <a:ln/>
+        </p:spPr>
+        <p:txBody>
+          <a:bodyPr wrap="square" lIns="0" tIns="0" rIns="0" bIns="0" rtlCol="0" anchor="t"/>
+          <a:lstStyle/>
+          <a:p>
+            <a:pPr indent="0" marL="0">
+              <a:buNone/>
+            </a:pPr>
+            <a:r>
+              <a:rPr lang="en-US" sz="1200" dirty="0">
                 <a:solidFill>
                   <a:schemeClr val="tx1"/>
                 </a:solidFill>
               </a:rPr>
-              <a:t>Matches both catalogue periods: Gaia DR3 6.8494 d, VSX 6.8495 d</a:t>
-            </a:r>
-            <a:endParaRPr lang="en-US" sz="1500" dirty="0"/>
+              <a:t>22 µm (W4) excess above the binary</a:t>
+            </a:r>
+            <a:endParaRPr lang="en-US" sz="1200" dirty="0"/>
+          </a:p>
+        </p:txBody>
+      </p:sp>
+      <p:sp>
+        <p:nvSpPr>
+          <p:cNvPr id="12" name="Text 10"/>
+          <p:cNvSpPr txBox="1"/>
+          <p:nvPr/>
+        </p:nvSpPr>
+        <p:spPr>
+          <a:xfrm>
+            <a:off x="457200" y="3200400"/>
+            <a:ext cx="8229600" cy="914400"/>
+          </a:xfrm>
+          <a:prstGeom prst="rect">
+            <a:avLst/>
+          </a:prstGeom>
+          <a:noFill/>
+          <a:ln/>
+        </p:spPr>
+        <p:txBody>
+          <a:bodyPr wrap="square" lIns="0" tIns="0" rIns="0" bIns="0" rtlCol="0" anchor="t"/>
+          <a:lstStyle/>
+          <a:p>
+            <a:pPr indent="0" marL="0">
+              <a:buNone/>
+            </a:pPr>
+            <a:r>
+              <a:rPr lang="en-US" sz="1600" dirty="0">
+                <a:solidFill>
+                  <a:schemeClr val="tx1"/>
+                </a:solidFill>
+              </a:rPr>
+              <a:t>The excess is real and not from a neighbour, but the star sits on extended dust emission, so a disk is not yet proven.</a:t>
+            </a:r>
+            <a:endParaRPr lang="en-US" sz="1600" dirty="0"/>
           </a:p>
         </p:txBody>
       </p:sp>
@@ -2732,6 +3353,253 @@
                 <a:ea typeface="+mj-lt" pitchFamily="34" charset="-122"/>
                 <a:cs typeface="+mj-lt" pitchFamily="34" charset="-120"/>
               </a:rPr>
+              <a:t>Unequal eclipse depths fix the period at 6.85 d</a:t>
+            </a:r>
+            <a:endParaRPr lang="en-US" sz="2200" dirty="0"/>
+          </a:p>
+        </p:txBody>
+      </p:sp>
+      <p:pic>
+        <p:nvPicPr>
+          <p:cNvPr id="3" name="Image 0" descr="/tmp/claude-0/-home-claude-tic-106588577-phoebe/9801b85f-ee4b-5050-ac26-be5ee36f67a6/scratchpad/deck/img/ecl.jpg">    </p:cNvPr>
+          <p:cNvPicPr>
+            <a:picLocks noChangeAspect="1"/>
+          </p:cNvPicPr>
+          <p:nvPr/>
+        </p:nvPicPr>
+        <p:blipFill>
+          <a:blip r:embed="rId1"/>
+          <a:stretch>
+            <a:fillRect/>
+          </a:stretch>
+        </p:blipFill>
+        <p:spPr>
+          <a:xfrm>
+            <a:off x="457200" y="1188720"/>
+            <a:ext cx="5394960" cy="2779776"/>
+          </a:xfrm>
+          <a:prstGeom prst="rect">
+            <a:avLst/>
+          </a:prstGeom>
+        </p:spPr>
+      </p:pic>
+      <p:sp>
+        <p:nvSpPr>
+          <p:cNvPr id="4" name="Text 1"/>
+          <p:cNvSpPr txBox="1"/>
+          <p:nvPr/>
+        </p:nvSpPr>
+        <p:spPr>
+          <a:xfrm>
+            <a:off x="457200" y="4069080"/>
+            <a:ext cx="5394960" cy="274320"/>
+          </a:xfrm>
+          <a:prstGeom prst="rect">
+            <a:avLst/>
+          </a:prstGeom>
+          <a:noFill/>
+          <a:ln/>
+        </p:spPr>
+        <p:txBody>
+          <a:bodyPr wrap="square" lIns="0" tIns="0" rIns="0" bIns="0" rtlCol="0" anchor="ctr"/>
+          <a:lstStyle/>
+          <a:p>
+            <a:pPr indent="0" marL="0">
+              <a:buNone/>
+            </a:pPr>
+            <a:r>
+              <a:rPr lang="en-US" sz="1000" i="1" dirty="0">
+                <a:solidFill>
+                  <a:schemeClr val="accent2"/>
+                </a:solidFill>
+              </a:rPr>
+              <a:t>Stacked eclipses in TESS sectors 16, 17 and 57. Blue = primary, red = secondary.</a:t>
+            </a:r>
+            <a:endParaRPr lang="en-US" sz="1000" dirty="0"/>
+          </a:p>
+        </p:txBody>
+      </p:sp>
+      <p:sp>
+        <p:nvSpPr>
+          <p:cNvPr id="5" name="Text 2"/>
+          <p:cNvSpPr txBox="1"/>
+          <p:nvPr/>
+        </p:nvSpPr>
+        <p:spPr>
+          <a:xfrm>
+            <a:off x="6035040" y="1280160"/>
+            <a:ext cx="2651760" cy="2743200"/>
+          </a:xfrm>
+          <a:prstGeom prst="rect">
+            <a:avLst/>
+          </a:prstGeom>
+          <a:noFill/>
+          <a:ln/>
+        </p:spPr>
+        <p:txBody>
+          <a:bodyPr wrap="square" rtlCol="0" anchor="t"/>
+          <a:lstStyle/>
+          <a:p>
+            <a:pPr marL="342900" indent="-342900">
+              <a:spcAft>
+                <a:spcPts val="600"/>
+              </a:spcAft>
+              <a:buSzPct val="100000"/>
+              <a:buChar char="•"/>
+            </a:pPr>
+            <a:r>
+              <a:rPr lang="en-US" sz="1500" dirty="0">
+                <a:solidFill>
+                  <a:schemeClr val="tx1"/>
+                </a:solidFill>
+              </a:rPr>
+              <a:t>Primary is deeper than secondary (118σ)</a:t>
+            </a:r>
+            <a:endParaRPr lang="en-US" sz="1500" dirty="0"/>
+          </a:p>
+          <a:p>
+            <a:pPr marL="342900" indent="-342900">
+              <a:spcAft>
+                <a:spcPts val="600"/>
+              </a:spcAft>
+              <a:buSzPct val="100000"/>
+              <a:buChar char="•"/>
+            </a:pPr>
+            <a:r>
+              <a:rPr lang="en-US" sz="1500" dirty="0">
+                <a:solidFill>
+                  <a:schemeClr val="tx1"/>
+                </a:solidFill>
+              </a:rPr>
+              <a:t>Secondary is 16 min early: slight eccentricity</a:t>
+            </a:r>
+            <a:endParaRPr lang="en-US" sz="1500" dirty="0"/>
+          </a:p>
+          <a:p>
+            <a:pPr marL="342900" indent="-342900">
+              <a:spcAft>
+                <a:spcPts val="600"/>
+              </a:spcAft>
+              <a:buSzPct val="100000"/>
+              <a:buChar char="•"/>
+            </a:pPr>
+            <a:r>
+              <a:rPr lang="en-US" sz="1500" dirty="0">
+                <a:solidFill>
+                  <a:schemeClr val="tx1"/>
+                </a:solidFill>
+              </a:rPr>
+              <a:t>Matches both catalogue periods: Gaia DR3 6.8494 d, VSX 6.8495 d</a:t>
+            </a:r>
+            <a:endParaRPr lang="en-US" sz="1500" dirty="0"/>
+          </a:p>
+        </p:txBody>
+      </p:sp>
+      <p:sp>
+        <p:nvSpPr>
+          <p:cNvPr id="25" name="Slide Number Placeholder 0"/>
+          <p:cNvSpPr>
+            <a:spLocks noGrp="1"/>
+          </p:cNvSpPr>
+          <p:nvPr>
+            <p:ph type="sldNum" sz="quarter" idx="4294967295"/>
+          </p:nvPr>
+        </p:nvSpPr>
+        <p:spPr>
+          <a:xfrm>
+            <a:off x="8412480" y="4800600"/>
+            <a:ext cx="457200" cy="228600"/>
+          </a:xfrm>
+          <a:prstGeom prst="rect">
+            <a:avLst/>
+          </a:prstGeom>
+          <a:extLst>
+            <a:ext uri="{C572A759-6A51-4108-AA02-DFA0A04FC94B}">
+              <ma14:wrappingTextBoxFlag xmlns:ma14="http://schemas.microsoft.com/office/mac/drawingml/2011/main" val="0"/>
+            </a:ext>
+          </a:extLst>
+        </p:spPr>
+        <p:txBody>
+          <a:bodyPr/>
+          <a:lstStyle>
+            <a:lvl1pPr>
+              <a:defRPr sz="900">
+                <a:solidFill>
+                  <a:srgbClr val="8A94A8"/>
+                </a:solidFill>
+              </a:defRPr>
+            </a:lvl1pPr>
+          </a:lstStyle>
+          <a:p>
+            <a:pPr algn="l"/>
+            <a:fld id="{F7021451-1387-4CA6-816F-3879F97B5CBC}" type="slidenum">
+              <a:rPr b="0" lang="en-US"/>
+              <a:t>4</a:t>
+            </a:fld>
+            <a:endParaRPr lang="en-US"/>
+          </a:p>
+        </p:txBody>
+      </p:sp>
+    </p:spTree>
+  </p:cSld>
+  <p:clrMapOvr>
+    <a:masterClrMapping/>
+  </p:clrMapOvr>
+</p:sld>
+</file>
+
+<file path=ppt/slides/slide5.xml><?xml version="1.0" encoding="utf-8"?>
+<p:sld xmlns:a="http://schemas.openxmlformats.org/drawingml/2006/main" xmlns:r="http://schemas.openxmlformats.org/officeDocument/2006/relationships" xmlns:p="http://schemas.openxmlformats.org/presentationml/2006/main">
+  <p:cSld name="Slide 5">
+    <p:spTree>
+      <p:nvGrpSpPr>
+        <p:cNvPr id="1" name=""/>
+        <p:cNvGrpSpPr/>
+        <p:nvPr/>
+      </p:nvGrpSpPr>
+      <p:grpSpPr>
+        <a:xfrm>
+          <a:off x="0" y="0"/>
+          <a:ext cx="0" cy="0"/>
+          <a:chOff x="0" y="0"/>
+          <a:chExt cx="0" cy="0"/>
+        </a:xfrm>
+      </p:grpSpPr>
+      <p:sp>
+        <p:nvSpPr>
+          <p:cNvPr id="2" name="Text 0"/>
+          <p:cNvSpPr/>
+          <p:nvPr>
+            <p:ph idx="100" type="title" hasCustomPrompt="1"/>
+          </p:nvPr>
+        </p:nvSpPr>
+        <p:spPr>
+          <a:xfrm>
+            <a:off x="457200" y="274320"/>
+            <a:ext cx="8229600" cy="777240"/>
+          </a:xfrm>
+          <a:prstGeom prst="rect">
+            <a:avLst/>
+          </a:prstGeom>
+          <a:noFill/>
+          <a:ln/>
+        </p:spPr>
+        <p:txBody>
+          <a:bodyPr wrap="square" rtlCol="0" anchor="ctr"/>
+          <a:lstStyle/>
+          <a:p>
+            <a:pPr indent="0" marL="0">
+              <a:buNone/>
+            </a:pPr>
+            <a:r>
+              <a:rPr lang="en-US" sz="2200" b="1" dirty="0">
+                <a:solidFill>
+                  <a:schemeClr val="tx2"/>
+                </a:solidFill>
+                <a:latin typeface="+mj-lt" pitchFamily="34" charset="0"/>
+                <a:ea typeface="+mj-lt" pitchFamily="34" charset="-122"/>
+                <a:cs typeface="+mj-lt" pitchFamily="34" charset="-120"/>
+              </a:rPr>
               <a:t>Two near-twin A stars on a nearly circular orbit</a:t>
             </a:r>
             <a:endParaRPr lang="en-US" sz="2200" dirty="0"/>
@@ -2800,7 +3668,7 @@
       </p:sp>
       <p:graphicFrame>
         <p:nvGraphicFramePr>
-          <p:cNvPr id="5" name="Table 0"/>
+          <p:cNvPr id="6" name="Table 0"/>
           <p:cNvGraphicFramePr>
             <a:graphicFrameLocks noGrp="1"/>
           </p:cNvGraphicFramePr>
@@ -3523,235 +4391,6 @@
             <a:pPr algn="l"/>
             <a:fld id="{F7021451-1387-4CA6-816F-3879F97B5CBC}" type="slidenum">
               <a:rPr b="0" lang="en-US"/>
-              <a:t>4</a:t>
-            </a:fld>
-            <a:endParaRPr lang="en-US"/>
-          </a:p>
-        </p:txBody>
-      </p:sp>
-    </p:spTree>
-  </p:cSld>
-  <p:clrMapOvr>
-    <a:masterClrMapping/>
-  </p:clrMapOvr>
-</p:sld>
-</file>
-
-<file path=ppt/slides/slide5.xml><?xml version="1.0" encoding="utf-8"?>
-<p:sld xmlns:a="http://schemas.openxmlformats.org/drawingml/2006/main" xmlns:r="http://schemas.openxmlformats.org/officeDocument/2006/relationships" xmlns:p="http://schemas.openxmlformats.org/presentationml/2006/main">
-  <p:cSld name="Slide 5">
-    <p:spTree>
-      <p:nvGrpSpPr>
-        <p:cNvPr id="1" name=""/>
-        <p:cNvGrpSpPr/>
-        <p:nvPr/>
-      </p:nvGrpSpPr>
-      <p:grpSpPr>
-        <a:xfrm>
-          <a:off x="0" y="0"/>
-          <a:ext cx="0" cy="0"/>
-          <a:chOff x="0" y="0"/>
-          <a:chExt cx="0" cy="0"/>
-        </a:xfrm>
-      </p:grpSpPr>
-      <p:sp>
-        <p:nvSpPr>
-          <p:cNvPr id="2" name="Text 0"/>
-          <p:cNvSpPr/>
-          <p:nvPr>
-            <p:ph idx="100" type="title" hasCustomPrompt="1"/>
-          </p:nvPr>
-        </p:nvSpPr>
-        <p:spPr>
-          <a:xfrm>
-            <a:off x="457200" y="274320"/>
-            <a:ext cx="8229600" cy="777240"/>
-          </a:xfrm>
-          <a:prstGeom prst="rect">
-            <a:avLst/>
-          </a:prstGeom>
-          <a:noFill/>
-          <a:ln/>
-        </p:spPr>
-        <p:txBody>
-          <a:bodyPr wrap="square" rtlCol="0" anchor="ctr"/>
-          <a:lstStyle/>
-          <a:p>
-            <a:pPr indent="0" marL="0">
-              <a:buNone/>
-            </a:pPr>
-            <a:r>
-              <a:rPr lang="en-US" sz="2200" b="1" dirty="0">
-                <a:solidFill>
-                  <a:schemeClr val="tx2"/>
-                </a:solidFill>
-                <a:latin typeface="+mj-lt" pitchFamily="34" charset="0"/>
-                <a:ea typeface="+mj-lt" pitchFamily="34" charset="-122"/>
-                <a:cs typeface="+mj-lt" pitchFamily="34" charset="-120"/>
-              </a:rPr>
-              <a:t>W4 is 3.6× brighter than the binary predicts</a:t>
-            </a:r>
-            <a:endParaRPr lang="en-US" sz="2200" dirty="0"/>
-          </a:p>
-        </p:txBody>
-      </p:sp>
-      <p:pic>
-        <p:nvPicPr>
-          <p:cNvPr id="3" name="Image 0" descr="/tmp/claude-0/-home-claude-tic-106588577-phoebe/9801b85f-ee4b-5050-ac26-be5ee36f67a6/scratchpad/deck/img/sed.jpg">    </p:cNvPr>
-          <p:cNvPicPr>
-            <a:picLocks noChangeAspect="1"/>
-          </p:cNvPicPr>
-          <p:nvPr/>
-        </p:nvPicPr>
-        <p:blipFill>
-          <a:blip r:embed="rId1"/>
-          <a:stretch>
-            <a:fillRect/>
-          </a:stretch>
-        </p:blipFill>
-        <p:spPr>
-          <a:xfrm>
-            <a:off x="457200" y="1097280"/>
-            <a:ext cx="4754880" cy="3291840"/>
-          </a:xfrm>
-          <a:prstGeom prst="rect">
-            <a:avLst/>
-          </a:prstGeom>
-        </p:spPr>
-      </p:pic>
-      <p:sp>
-        <p:nvSpPr>
-          <p:cNvPr id="4" name="Text 1"/>
-          <p:cNvSpPr txBox="1"/>
-          <p:nvPr/>
-        </p:nvSpPr>
-        <p:spPr>
-          <a:xfrm>
-            <a:off x="457200" y="4462272"/>
-            <a:ext cx="4754880" cy="274320"/>
-          </a:xfrm>
-          <a:prstGeom prst="rect">
-            <a:avLst/>
-          </a:prstGeom>
-          <a:noFill/>
-          <a:ln/>
-        </p:spPr>
-        <p:txBody>
-          <a:bodyPr wrap="square" lIns="0" tIns="0" rIns="0" bIns="0" rtlCol="0" anchor="ctr"/>
-          <a:lstStyle/>
-          <a:p>
-            <a:pPr indent="0" marL="0">
-              <a:buNone/>
-            </a:pPr>
-            <a:r>
-              <a:rPr lang="en-US" sz="1000" i="1" dirty="0">
-                <a:solidFill>
-                  <a:schemeClr val="accent2"/>
-                </a:solidFill>
-              </a:rPr>
-              <a:t>2MASS + AllWISE photometry (black) vs the binary photosphere (blue).</a:t>
-            </a:r>
-            <a:endParaRPr lang="en-US" sz="1000" dirty="0"/>
-          </a:p>
-        </p:txBody>
-      </p:sp>
-      <p:sp>
-        <p:nvSpPr>
-          <p:cNvPr id="5" name="Text 2"/>
-          <p:cNvSpPr txBox="1"/>
-          <p:nvPr/>
-        </p:nvSpPr>
-        <p:spPr>
-          <a:xfrm>
-            <a:off x="5486400" y="1280160"/>
-            <a:ext cx="3200400" cy="2743200"/>
-          </a:xfrm>
-          <a:prstGeom prst="rect">
-            <a:avLst/>
-          </a:prstGeom>
-          <a:noFill/>
-          <a:ln/>
-        </p:spPr>
-        <p:txBody>
-          <a:bodyPr wrap="square" rtlCol="0" anchor="t"/>
-          <a:lstStyle/>
-          <a:p>
-            <a:pPr marL="342900" indent="-342900">
-              <a:spcAft>
-                <a:spcPts val="600"/>
-              </a:spcAft>
-              <a:buSzPct val="100000"/>
-              <a:buChar char="•"/>
-            </a:pPr>
-            <a:r>
-              <a:rPr lang="en-US" sz="1500" dirty="0">
-                <a:solidFill>
-                  <a:schemeClr val="tx1"/>
-                </a:solidFill>
-              </a:rPr>
-              <a:t>Near-IR matches the photosphere</a:t>
-            </a:r>
-            <a:endParaRPr lang="en-US" sz="1500" dirty="0"/>
-          </a:p>
-          <a:p>
-            <a:pPr marL="342900" indent="-342900">
-              <a:spcAft>
-                <a:spcPts val="600"/>
-              </a:spcAft>
-              <a:buSzPct val="100000"/>
-              <a:buChar char="•"/>
-            </a:pPr>
-            <a:r>
-              <a:rPr lang="en-US" sz="1500" dirty="0">
-                <a:solidFill>
-                  <a:schemeClr val="tx1"/>
-                </a:solidFill>
-              </a:rPr>
-              <a:t>Excess: W3 7.0σ, W4 12.6σ</a:t>
-            </a:r>
-            <a:endParaRPr lang="en-US" sz="1500" dirty="0"/>
-          </a:p>
-        </p:txBody>
-      </p:sp>
-      <p:sp>
-        <p:nvSpPr>
-          <p:cNvPr id="25" name="Slide Number Placeholder 0"/>
-          <p:cNvSpPr>
-            <a:spLocks noGrp="1"/>
-          </p:cNvSpPr>
-          <p:nvPr>
-            <p:ph type="sldNum" sz="quarter" idx="4294967295"/>
-          </p:nvPr>
-        </p:nvSpPr>
-        <p:spPr>
-          <a:xfrm>
-            <a:off x="8412480" y="4800600"/>
-            <a:ext cx="457200" cy="228600"/>
-          </a:xfrm>
-          <a:prstGeom prst="rect">
-            <a:avLst/>
-          </a:prstGeom>
-          <a:extLst>
-            <a:ext uri="{C572A759-6A51-4108-AA02-DFA0A04FC94B}">
-              <ma14:wrappingTextBoxFlag xmlns:ma14="http://schemas.microsoft.com/office/mac/drawingml/2011/main" val="0"/>
-            </a:ext>
-          </a:extLst>
-        </p:spPr>
-        <p:txBody>
-          <a:bodyPr/>
-          <a:lstStyle>
-            <a:lvl1pPr>
-              <a:defRPr sz="900">
-                <a:solidFill>
-                  <a:srgbClr val="8A94A8"/>
-                </a:solidFill>
-              </a:defRPr>
-            </a:lvl1pPr>
-          </a:lstStyle>
-          <a:p>
-            <a:pPr algn="l"/>
-            <a:fld id="{F7021451-1387-4CA6-816F-3879F97B5CBC}" type="slidenum">
-              <a:rPr b="0" lang="en-US"/>
               <a:t>5</a:t>
             </a:fld>
             <a:endParaRPr lang="en-US"/>
@@ -3818,7 +4457,7 @@
                 <a:ea typeface="+mj-lt" pitchFamily="34" charset="-122"/>
                 <a:cs typeface="+mj-lt" pitchFamily="34" charset="-120"/>
               </a:rPr>
-              <a:t>AllWISE images: the star sits on a ridge of dust emission</a:t>
+              <a:t>W4 is 3.6× brighter than the binary predicts</a:t>
             </a:r>
             <a:endParaRPr lang="en-US" sz="2200" dirty="0"/>
           </a:p>
@@ -3826,7 +4465,7 @@
       </p:sp>
       <p:pic>
         <p:nvPicPr>
-          <p:cNvPr id="3" name="Image 0" descr="/tmp/claude-0/-home-claude-tic-106588577-phoebe/9801b85f-ee4b-5050-ac26-be5ee36f67a6/scratchpad/deck/img/wide_hi.jpg">    </p:cNvPr>
+          <p:cNvPr id="3" name="Image 0" descr="/tmp/claude-0/-home-claude-tic-106588577-phoebe/9801b85f-ee4b-5050-ac26-be5ee36f67a6/scratchpad/deck/img/sed.jpg">    </p:cNvPr>
           <p:cNvPicPr>
             <a:picLocks noChangeAspect="1"/>
           </p:cNvPicPr>
@@ -3840,8 +4479,8 @@
         </p:blipFill>
         <p:spPr>
           <a:xfrm>
-            <a:off x="1234440" y="1051560"/>
-            <a:ext cx="6675120" cy="3474720"/>
+            <a:off x="457200" y="1097280"/>
+            <a:ext cx="4754880" cy="3291840"/>
           </a:xfrm>
           <a:prstGeom prst="rect">
             <a:avLst/>
@@ -3856,8 +4495,8 @@
         </p:nvSpPr>
         <p:spPr>
           <a:xfrm>
-            <a:off x="1234440" y="4572000"/>
-            <a:ext cx="6675120" cy="274320"/>
+            <a:off x="457200" y="4462272"/>
+            <a:ext cx="4754880" cy="274320"/>
           </a:xfrm>
           <a:prstGeom prst="rect">
             <a:avLst/>
@@ -3878,9 +4517,67 @@
                   <a:schemeClr val="accent2"/>
                 </a:solidFill>
               </a:rPr>
-              <a:t>10′ × 10′ AllWISE W3 (12 µm, left) and W4 (22 µm, right). Cyan circle = the star; green = faint neighbours.</a:t>
+              <a:t>2MASS + AllWISE photometry (black) vs the binary photosphere (blue).</a:t>
             </a:r>
             <a:endParaRPr lang="en-US" sz="1000" dirty="0"/>
+          </a:p>
+        </p:txBody>
+      </p:sp>
+      <p:sp>
+        <p:nvSpPr>
+          <p:cNvPr id="5" name="Text 2"/>
+          <p:cNvSpPr txBox="1"/>
+          <p:nvPr/>
+        </p:nvSpPr>
+        <p:spPr>
+          <a:xfrm>
+            <a:off x="5486400" y="1280160"/>
+            <a:ext cx="3200400" cy="2743200"/>
+          </a:xfrm>
+          <a:prstGeom prst="rect">
+            <a:avLst/>
+          </a:prstGeom>
+          <a:noFill/>
+          <a:ln/>
+        </p:spPr>
+        <p:txBody>
+          <a:bodyPr wrap="square" rtlCol="0" anchor="t"/>
+          <a:lstStyle/>
+          <a:p>
+            <a:pPr marL="342900" indent="-342900">
+              <a:spcAft>
+                <a:spcPts val="600"/>
+              </a:spcAft>
+              <a:buSzPct val="100000"/>
+              <a:buChar char="•"/>
+            </a:pPr>
+            <a:r>
+              <a:rPr lang="en-US" sz="1500" dirty="0">
+                <a:solidFill>
+                  <a:schemeClr val="tx1"/>
+                </a:solidFill>
+              </a:rPr>
+              <a:t>Near-IR matches the photosphere</a:t>
+            </a:r>
+            <a:endParaRPr lang="en-US" sz="1500" dirty="0"/>
+          </a:p>
+          <a:p>
+            <a:pPr marL="342900" indent="-342900">
+              <a:spcAft>
+                <a:spcPts val="600"/>
+              </a:spcAft>
+              <a:buSzPct val="100000"/>
+              <a:buChar char="•"/>
+            </a:pPr>
+            <a:r>
+              <a:rPr lang="en-US" sz="1500" dirty="0">
+                <a:solidFill>
+                  <a:schemeClr val="tx1"/>
+                </a:solidFill>
+              </a:rPr>
+              <a:t>Excess: W3 7.0σ, W4 12.6σ</a:t>
+            </a:r>
+            <a:endParaRPr lang="en-US" sz="1500" dirty="0"/>
           </a:p>
         </p:txBody>
       </p:sp>
@@ -3989,7 +4686,7 @@
                 <a:ea typeface="+mj-lt" pitchFamily="34" charset="-122"/>
                 <a:cs typeface="+mj-lt" pitchFamily="34" charset="-120"/>
               </a:rPr>
-              <a:t>But the 22 µm light is extended, not a point source</a:t>
+              <a:t>AllWISE images: the star sits on a ridge of dust emission</a:t>
             </a:r>
             <a:endParaRPr lang="en-US" sz="2200" dirty="0"/>
           </a:p>
@@ -3997,7 +4694,7 @@
       </p:sp>
       <p:pic>
         <p:nvPicPr>
-          <p:cNvPr id="3" name="Image 0" descr="/tmp/claude-0/-home-claude-tic-106588577-phoebe/9801b85f-ee4b-5050-ac26-be5ee36f67a6/scratchpad/deck/img/zoom.jpg">    </p:cNvPr>
+          <p:cNvPr id="3" name="Image 0" descr="/tmp/claude-0/-home-claude-tic-106588577-phoebe/9801b85f-ee4b-5050-ac26-be5ee36f67a6/scratchpad/deck/img/wide_hi.jpg">    </p:cNvPr>
           <p:cNvPicPr>
             <a:picLocks noChangeAspect="1"/>
           </p:cNvPicPr>
@@ -4011,8 +4708,8 @@
         </p:blipFill>
         <p:spPr>
           <a:xfrm>
-            <a:off x="457200" y="1143000"/>
-            <a:ext cx="8229600" cy="2724912"/>
+            <a:off x="1234440" y="1051560"/>
+            <a:ext cx="6675120" cy="3474720"/>
           </a:xfrm>
           <a:prstGeom prst="rect">
             <a:avLst/>
@@ -4027,8 +4724,8 @@
         </p:nvSpPr>
         <p:spPr>
           <a:xfrm>
-            <a:off x="457200" y="3931920"/>
-            <a:ext cx="8229600" cy="274320"/>
+            <a:off x="1234440" y="4572000"/>
+            <a:ext cx="6675120" cy="274320"/>
           </a:xfrm>
           <a:prstGeom prst="rect">
             <a:avLst/>
@@ -4049,45 +4746,9 @@
                   <a:schemeClr val="accent2"/>
                 </a:solidFill>
               </a:rPr>
-              <a:t>4′ × 4′ W3 and W4 cutouts and radial profiles.</a:t>
+              <a:t>10′ × 10′ AllWISE W3 (12 µm, left) and W4 (22 µm, right). Cyan circle = the star; green = faint neighbours.</a:t>
             </a:r>
             <a:endParaRPr lang="en-US" sz="1000" dirty="0"/>
-          </a:p>
-        </p:txBody>
-      </p:sp>
-      <p:sp>
-        <p:nvSpPr>
-          <p:cNvPr id="5" name="Text 2"/>
-          <p:cNvSpPr txBox="1"/>
-          <p:nvPr/>
-        </p:nvSpPr>
-        <p:spPr>
-          <a:xfrm>
-            <a:off x="457200" y="4251960"/>
-            <a:ext cx="8229600" cy="548640"/>
-          </a:xfrm>
-          <a:prstGeom prst="rect">
-            <a:avLst/>
-          </a:prstGeom>
-          <a:noFill/>
-          <a:ln/>
-        </p:spPr>
-        <p:txBody>
-          <a:bodyPr wrap="square" lIns="0" tIns="0" rIns="0" bIns="0" rtlCol="0" anchor="ctr"/>
-          <a:lstStyle/>
-          <a:p>
-            <a:pPr indent="0" marL="0">
-              <a:buNone/>
-            </a:pPr>
-            <a:r>
-              <a:rPr lang="en-US" sz="1300" dirty="0">
-                <a:solidFill>
-                  <a:schemeClr val="tx1"/>
-                </a:solidFill>
-              </a:rPr>
-              <a:t>W4 stays at 15–20% of peak out to 100″; a point source would fade within ~30″. The star sits on a ridge of dust emission.</a:t>
-            </a:r>
-            <a:endParaRPr lang="en-US" sz="1300" dirty="0"/>
           </a:p>
         </p:txBody>
       </p:sp>
@@ -4196,49 +4857,46 @@
                 <a:ea typeface="+mj-lt" pitchFamily="34" charset="-122"/>
                 <a:cs typeface="+mj-lt" pitchFamily="34" charset="-120"/>
               </a:rPr>
-              <a:t>No neighbour explains the excess or dilutes the eclipses</a:t>
+              <a:t>But the 22 µm light is extended, not a point source</a:t>
             </a:r>
             <a:endParaRPr lang="en-US" sz="2200" dirty="0"/>
           </a:p>
         </p:txBody>
       </p:sp>
-      <p:sp>
-        <p:nvSpPr>
-          <p:cNvPr id="3" name="card"/>
-          <p:cNvSpPr/>
+      <p:pic>
+        <p:nvPicPr>
+          <p:cNvPr id="3" name="Image 0" descr="/tmp/claude-0/-home-claude-tic-106588577-phoebe/9801b85f-ee4b-5050-ac26-be5ee36f67a6/scratchpad/deck/img/zoom.jpg">    </p:cNvPr>
+          <p:cNvPicPr>
+            <a:picLocks noChangeAspect="1"/>
+          </p:cNvPicPr>
           <p:nvPr/>
-        </p:nvSpPr>
-        <p:spPr>
-          <a:xfrm>
-            <a:off x="457200" y="1234440"/>
-            <a:ext cx="2606040" cy="1828800"/>
-          </a:xfrm>
-          <a:prstGeom prst="roundRect">
-            <a:avLst>
-              <a:gd name="adj" fmla="val 4000"/>
-            </a:avLst>
-          </a:prstGeom>
-          <a:solidFill>
-            <a:schemeClr val="bg1"/>
-          </a:solidFill>
-          <a:ln w="9525">
-            <a:solidFill>
-              <a:srgbClr val="C8CEDB"/>
-            </a:solidFill>
-            <a:prstDash val="solid"/>
-          </a:ln>
-        </p:spPr>
-      </p:sp>
-      <p:sp>
-        <p:nvSpPr>
-          <p:cNvPr id="4" name="Text 2"/>
+        </p:nvPicPr>
+        <p:blipFill>
+          <a:blip r:embed="rId1"/>
+          <a:stretch>
+            <a:fillRect/>
+          </a:stretch>
+        </p:blipFill>
+        <p:spPr>
+          <a:xfrm>
+            <a:off x="457200" y="1143000"/>
+            <a:ext cx="8229600" cy="2724912"/>
+          </a:xfrm>
+          <a:prstGeom prst="rect">
+            <a:avLst/>
+          </a:prstGeom>
+        </p:spPr>
+      </p:pic>
+      <p:sp>
+        <p:nvSpPr>
+          <p:cNvPr id="4" name="Text 1"/>
           <p:cNvSpPr txBox="1"/>
           <p:nvPr/>
         </p:nvSpPr>
         <p:spPr>
           <a:xfrm>
-            <a:off x="594360" y="1344168"/>
-            <a:ext cx="2331720" cy="685800"/>
+            <a:off x="457200" y="3931920"/>
+            <a:ext cx="8229600" cy="274320"/>
           </a:xfrm>
           <a:prstGeom prst="rect">
             <a:avLst/>
@@ -4254,30 +4912,27 @@
               <a:buNone/>
             </a:pPr>
             <a:r>
-              <a:rPr lang="en-US" sz="3000" b="1" dirty="0">
-                <a:solidFill>
-                  <a:schemeClr val="accent1"/>
-                </a:solidFill>
-                <a:latin typeface="+mj-lt" pitchFamily="34" charset="0"/>
-                <a:ea typeface="+mj-lt" pitchFamily="34" charset="-122"/>
-                <a:cs typeface="+mj-lt" pitchFamily="34" charset="-120"/>
+              <a:rPr lang="en-US" sz="1000" i="1" dirty="0">
+                <a:solidFill>
+                  <a:schemeClr val="accent2"/>
+                </a:solidFill>
               </a:rPr>
-              <a:t>≤ 4.1</a:t>
-            </a:r>
-            <a:endParaRPr lang="en-US" sz="3000" dirty="0"/>
-          </a:p>
-        </p:txBody>
-      </p:sp>
-      <p:sp>
-        <p:nvSpPr>
-          <p:cNvPr id="5" name="Text 3"/>
+              <a:t>4′ × 4′ W3 and W4 cutouts and radial profiles.</a:t>
+            </a:r>
+            <a:endParaRPr lang="en-US" sz="1000" dirty="0"/>
+          </a:p>
+        </p:txBody>
+      </p:sp>
+      <p:sp>
+        <p:nvSpPr>
+          <p:cNvPr id="5" name="Text 2"/>
           <p:cNvSpPr txBox="1"/>
           <p:nvPr/>
         </p:nvSpPr>
         <p:spPr>
           <a:xfrm>
-            <a:off x="594360" y="2057400"/>
-            <a:ext cx="2331720" cy="914400"/>
+            <a:off x="457200" y="4251960"/>
+            <a:ext cx="8229600" cy="548640"/>
           </a:xfrm>
           <a:prstGeom prst="rect">
             <a:avLst/>
@@ -4286,225 +4941,21 @@
           <a:ln/>
         </p:spPr>
         <p:txBody>
-          <a:bodyPr wrap="square" lIns="0" tIns="0" rIns="0" bIns="0" rtlCol="0" anchor="t"/>
+          <a:bodyPr wrap="square" lIns="0" tIns="0" rIns="0" bIns="0" rtlCol="0" anchor="ctr"/>
           <a:lstStyle/>
           <a:p>
             <a:pPr indent="0" marL="0">
               <a:buNone/>
             </a:pPr>
             <a:r>
-              <a:rPr lang="en-US" sz="1200" dirty="0">
+              <a:rPr lang="en-US" sz="1300" dirty="0">
                 <a:solidFill>
                   <a:schemeClr val="tx1"/>
                 </a:solidFill>
               </a:rPr>
-              <a:t>W4 SNR of any AllWISE source within 3′</a:t>
-            </a:r>
-            <a:endParaRPr lang="en-US" sz="1200" dirty="0"/>
-          </a:p>
-        </p:txBody>
-      </p:sp>
-      <p:sp>
-        <p:nvSpPr>
-          <p:cNvPr id="6" name="card"/>
-          <p:cNvSpPr/>
-          <p:nvPr/>
-        </p:nvSpPr>
-        <p:spPr>
-          <a:xfrm>
-            <a:off x="3268980" y="1234440"/>
-            <a:ext cx="2606040" cy="1828800"/>
-          </a:xfrm>
-          <a:prstGeom prst="roundRect">
-            <a:avLst>
-              <a:gd name="adj" fmla="val 4000"/>
-            </a:avLst>
-          </a:prstGeom>
-          <a:solidFill>
-            <a:schemeClr val="bg1"/>
-          </a:solidFill>
-          <a:ln w="9525">
-            <a:solidFill>
-              <a:srgbClr val="C8CEDB"/>
-            </a:solidFill>
-            <a:prstDash val="solid"/>
-          </a:ln>
-        </p:spPr>
-      </p:sp>
-      <p:sp>
-        <p:nvSpPr>
-          <p:cNvPr id="7" name="Text 5"/>
-          <p:cNvSpPr txBox="1"/>
-          <p:nvPr/>
-        </p:nvSpPr>
-        <p:spPr>
-          <a:xfrm>
-            <a:off x="3406140" y="1344168"/>
-            <a:ext cx="2331720" cy="685800"/>
-          </a:xfrm>
-          <a:prstGeom prst="rect">
-            <a:avLst/>
-          </a:prstGeom>
-          <a:noFill/>
-          <a:ln/>
-        </p:spPr>
-        <p:txBody>
-          <a:bodyPr wrap="square" lIns="0" tIns="0" rIns="0" bIns="0" rtlCol="0" anchor="ctr"/>
-          <a:lstStyle/>
-          <a:p>
-            <a:pPr indent="0" marL="0">
-              <a:buNone/>
-            </a:pPr>
-            <a:r>
-              <a:rPr lang="en-US" sz="3000" b="1" dirty="0">
-                <a:solidFill>
-                  <a:schemeClr val="accent3"/>
-                </a:solidFill>
-                <a:latin typeface="+mj-lt" pitchFamily="34" charset="0"/>
-                <a:ea typeface="+mj-lt" pitchFamily="34" charset="-122"/>
-                <a:cs typeface="+mj-lt" pitchFamily="34" charset="-120"/>
-              </a:rPr>
-              <a:t>0</a:t>
-            </a:r>
-            <a:endParaRPr lang="en-US" sz="3000" dirty="0"/>
-          </a:p>
-        </p:txBody>
-      </p:sp>
-      <p:sp>
-        <p:nvSpPr>
-          <p:cNvPr id="8" name="Text 6"/>
-          <p:cNvSpPr txBox="1"/>
-          <p:nvPr/>
-        </p:nvSpPr>
-        <p:spPr>
-          <a:xfrm>
-            <a:off x="3406140" y="2057400"/>
-            <a:ext cx="2331720" cy="914400"/>
-          </a:xfrm>
-          <a:prstGeom prst="rect">
-            <a:avLst/>
-          </a:prstGeom>
-          <a:noFill/>
-          <a:ln/>
-        </p:spPr>
-        <p:txBody>
-          <a:bodyPr wrap="square" lIns="0" tIns="0" rIns="0" bIns="0" rtlCol="0" anchor="t"/>
-          <a:lstStyle/>
-          <a:p>
-            <a:pPr indent="0" marL="0">
-              <a:buNone/>
-            </a:pPr>
-            <a:r>
-              <a:rPr lang="en-US" sz="1200" dirty="0">
-                <a:solidFill>
-                  <a:schemeClr val="tx1"/>
-                </a:solidFill>
-              </a:rPr>
-              <a:t>Gaia sources within 12″</a:t>
-            </a:r>
-            <a:endParaRPr lang="en-US" sz="1200" dirty="0"/>
-          </a:p>
-        </p:txBody>
-      </p:sp>
-      <p:sp>
-        <p:nvSpPr>
-          <p:cNvPr id="9" name="card"/>
-          <p:cNvSpPr/>
-          <p:nvPr/>
-        </p:nvSpPr>
-        <p:spPr>
-          <a:xfrm>
-            <a:off x="6080760" y="1234440"/>
-            <a:ext cx="2606040" cy="1828800"/>
-          </a:xfrm>
-          <a:prstGeom prst="roundRect">
-            <a:avLst>
-              <a:gd name="adj" fmla="val 4000"/>
-            </a:avLst>
-          </a:prstGeom>
-          <a:solidFill>
-            <a:schemeClr val="bg1"/>
-          </a:solidFill>
-          <a:ln w="9525">
-            <a:solidFill>
-              <a:srgbClr val="C8CEDB"/>
-            </a:solidFill>
-            <a:prstDash val="solid"/>
-          </a:ln>
-        </p:spPr>
-      </p:sp>
-      <p:sp>
-        <p:nvSpPr>
-          <p:cNvPr id="10" name="Text 8"/>
-          <p:cNvSpPr txBox="1"/>
-          <p:nvPr/>
-        </p:nvSpPr>
-        <p:spPr>
-          <a:xfrm>
-            <a:off x="6217920" y="1344168"/>
-            <a:ext cx="2331720" cy="685800"/>
-          </a:xfrm>
-          <a:prstGeom prst="rect">
-            <a:avLst/>
-          </a:prstGeom>
-          <a:noFill/>
-          <a:ln/>
-        </p:spPr>
-        <p:txBody>
-          <a:bodyPr wrap="square" lIns="0" tIns="0" rIns="0" bIns="0" rtlCol="0" anchor="ctr"/>
-          <a:lstStyle/>
-          <a:p>
-            <a:pPr indent="0" marL="0">
-              <a:buNone/>
-            </a:pPr>
-            <a:r>
-              <a:rPr lang="en-US" sz="3000" b="1" dirty="0">
-                <a:solidFill>
-                  <a:schemeClr val="accent3"/>
-                </a:solidFill>
-                <a:latin typeface="+mj-lt" pitchFamily="34" charset="0"/>
-                <a:ea typeface="+mj-lt" pitchFamily="34" charset="-122"/>
-                <a:cs typeface="+mj-lt" pitchFamily="34" charset="-120"/>
-              </a:rPr>
-              <a:t>1.8%</a:t>
-            </a:r>
-            <a:endParaRPr lang="en-US" sz="3000" dirty="0"/>
-          </a:p>
-        </p:txBody>
-      </p:sp>
-      <p:sp>
-        <p:nvSpPr>
-          <p:cNvPr id="11" name="Text 9"/>
-          <p:cNvSpPr txBox="1"/>
-          <p:nvPr/>
-        </p:nvSpPr>
-        <p:spPr>
-          <a:xfrm>
-            <a:off x="6217920" y="2057400"/>
-            <a:ext cx="2331720" cy="914400"/>
-          </a:xfrm>
-          <a:prstGeom prst="rect">
-            <a:avLst/>
-          </a:prstGeom>
-          <a:noFill/>
-          <a:ln/>
-        </p:spPr>
-        <p:txBody>
-          <a:bodyPr wrap="square" lIns="0" tIns="0" rIns="0" bIns="0" rtlCol="0" anchor="t"/>
-          <a:lstStyle/>
-          <a:p>
-            <a:pPr indent="0" marL="0">
-              <a:buNone/>
-            </a:pPr>
-            <a:r>
-              <a:rPr lang="en-US" sz="1200" dirty="0">
-                <a:solidFill>
-                  <a:schemeClr val="tx1"/>
-                </a:solidFill>
-              </a:rPr>
-              <a:t>Flux from Gaia sources at 12–60″ (TESS dilution)</a:t>
-            </a:r>
-            <a:endParaRPr lang="en-US" sz="1200" dirty="0"/>
+              <a:t>W4 stays at 15–20% of peak out to 100″; a point source would fade within ~30″. The star sits on a ridge of dust emission.</a:t>
+            </a:r>
+            <a:endParaRPr lang="en-US" sz="1300" dirty="0"/>
           </a:p>
         </p:txBody>
       </p:sp>
@@ -4588,8 +5039,8 @@
         </p:nvSpPr>
         <p:spPr>
           <a:xfrm>
-            <a:off x="548640" y="1371600"/>
-            <a:ext cx="8046720" cy="1371600"/>
+            <a:off x="457200" y="274320"/>
+            <a:ext cx="8229600" cy="777240"/>
           </a:xfrm>
           <a:prstGeom prst="rect">
             <a:avLst/>
@@ -4598,39 +5049,64 @@
           <a:ln/>
         </p:spPr>
         <p:txBody>
-          <a:bodyPr wrap="square" rtlCol="0" anchor="b"/>
+          <a:bodyPr wrap="square" rtlCol="0" anchor="ctr"/>
           <a:lstStyle/>
           <a:p>
             <a:pPr indent="0" marL="0">
               <a:buNone/>
             </a:pPr>
             <a:r>
-              <a:rPr lang="en-US" sz="3600" b="1" dirty="0">
-                <a:solidFill>
-                  <a:schemeClr val="bg1"/>
+              <a:rPr lang="en-US" sz="2200" b="1" dirty="0">
+                <a:solidFill>
+                  <a:schemeClr val="tx2"/>
                 </a:solidFill>
                 <a:latin typeface="+mj-lt" pitchFamily="34" charset="0"/>
                 <a:ea typeface="+mj-lt" pitchFamily="34" charset="-122"/>
                 <a:cs typeface="+mj-lt" pitchFamily="34" charset="-120"/>
               </a:rPr>
-              <a:t>Excess real, origin uncertain</a:t>
-            </a:r>
-            <a:endParaRPr lang="en-US" sz="3600" dirty="0"/>
-          </a:p>
-        </p:txBody>
-      </p:sp>
-      <p:sp>
-        <p:nvSpPr>
-          <p:cNvPr id="3" name="Text 0"/>
+              <a:t>No neighbour explains the excess or dilutes the eclipses</a:t>
+            </a:r>
+            <a:endParaRPr lang="en-US" sz="2200" dirty="0"/>
+          </a:p>
+        </p:txBody>
+      </p:sp>
+      <p:sp>
+        <p:nvSpPr>
+          <p:cNvPr id="3" name="card"/>
           <p:cNvSpPr/>
-          <p:nvPr>
-            <p:ph idx="101" type="body" hasCustomPrompt="1"/>
-          </p:nvPr>
-        </p:nvSpPr>
-        <p:spPr>
-          <a:xfrm>
-            <a:off x="548640" y="2880360"/>
-            <a:ext cx="8046720" cy="1097280"/>
+          <p:nvPr/>
+        </p:nvSpPr>
+        <p:spPr>
+          <a:xfrm>
+            <a:off x="457200" y="1234440"/>
+            <a:ext cx="2606040" cy="1828800"/>
+          </a:xfrm>
+          <a:prstGeom prst="roundRect">
+            <a:avLst>
+              <a:gd name="adj" fmla="val 4000"/>
+            </a:avLst>
+          </a:prstGeom>
+          <a:solidFill>
+            <a:schemeClr val="bg1"/>
+          </a:solidFill>
+          <a:ln w="9525">
+            <a:solidFill>
+              <a:srgbClr val="C8CEDB"/>
+            </a:solidFill>
+            <a:prstDash val="solid"/>
+          </a:ln>
+        </p:spPr>
+      </p:sp>
+      <p:sp>
+        <p:nvSpPr>
+          <p:cNvPr id="4" name="Text 2"/>
+          <p:cNvSpPr txBox="1"/>
+          <p:nvPr/>
+        </p:nvSpPr>
+        <p:spPr>
+          <a:xfrm>
+            <a:off x="594360" y="1344168"/>
+            <a:ext cx="2331720" cy="685800"/>
           </a:xfrm>
           <a:prstGeom prst="rect">
             <a:avLst/>
@@ -4639,32 +5115,309 @@
           <a:ln/>
         </p:spPr>
         <p:txBody>
-          <a:bodyPr wrap="square" rtlCol="0" anchor="t"/>
+          <a:bodyPr wrap="square" lIns="0" tIns="0" rIns="0" bIns="0" rtlCol="0" anchor="ctr"/>
           <a:lstStyle/>
           <a:p>
             <a:pPr indent="0" marL="0">
               <a:buNone/>
             </a:pPr>
             <a:r>
-              <a:rPr lang="en-US" sz="1600" b="1" dirty="0">
+              <a:rPr lang="en-US" sz="3000" b="1" dirty="0">
                 <a:solidFill>
                   <a:schemeClr val="accent1"/>
                 </a:solidFill>
+                <a:latin typeface="+mj-lt" pitchFamily="34" charset="0"/>
+                <a:ea typeface="+mj-lt" pitchFamily="34" charset="-122"/>
+                <a:cs typeface="+mj-lt" pitchFamily="34" charset="-120"/>
               </a:rPr>
-              <a:t>Next: </a:t>
-            </a:r>
+              <a:t>≤ 4.1</a:t>
+            </a:r>
+            <a:endParaRPr lang="en-US" sz="3000" dirty="0"/>
+          </a:p>
+        </p:txBody>
+      </p:sp>
+      <p:sp>
+        <p:nvSpPr>
+          <p:cNvPr id="5" name="Text 3"/>
+          <p:cNvSpPr txBox="1"/>
+          <p:nvPr/>
+        </p:nvSpPr>
+        <p:spPr>
+          <a:xfrm>
+            <a:off x="594360" y="2057400"/>
+            <a:ext cx="2331720" cy="914400"/>
+          </a:xfrm>
+          <a:prstGeom prst="rect">
+            <a:avLst/>
+          </a:prstGeom>
+          <a:noFill/>
+          <a:ln/>
+        </p:spPr>
+        <p:txBody>
+          <a:bodyPr wrap="square" lIns="0" tIns="0" rIns="0" bIns="0" rtlCol="0" anchor="t"/>
+          <a:lstStyle/>
+          <a:p>
             <a:pPr indent="0" marL="0">
               <a:buNone/>
             </a:pPr>
             <a:r>
-              <a:rPr lang="en-US" sz="1600" dirty="0">
-                <a:solidFill>
-                  <a:schemeClr val="accent4"/>
+              <a:rPr lang="en-US" sz="1200" dirty="0">
+                <a:solidFill>
+                  <a:schemeClr val="tx1"/>
                 </a:solidFill>
               </a:rPr>
-              <a:t>excess vs aperture size; Spitzer 24 µm or Herschel images; per-sector light-curve fit.</a:t>
-            </a:r>
-            <a:endParaRPr lang="en-US" sz="1600" dirty="0"/>
+              <a:t>W4 SNR of any AllWISE source within 3′</a:t>
+            </a:r>
+            <a:endParaRPr lang="en-US" sz="1200" dirty="0"/>
+          </a:p>
+        </p:txBody>
+      </p:sp>
+      <p:sp>
+        <p:nvSpPr>
+          <p:cNvPr id="6" name="card"/>
+          <p:cNvSpPr/>
+          <p:nvPr/>
+        </p:nvSpPr>
+        <p:spPr>
+          <a:xfrm>
+            <a:off x="3268980" y="1234440"/>
+            <a:ext cx="2606040" cy="1828800"/>
+          </a:xfrm>
+          <a:prstGeom prst="roundRect">
+            <a:avLst>
+              <a:gd name="adj" fmla="val 4000"/>
+            </a:avLst>
+          </a:prstGeom>
+          <a:solidFill>
+            <a:schemeClr val="bg1"/>
+          </a:solidFill>
+          <a:ln w="9525">
+            <a:solidFill>
+              <a:srgbClr val="C8CEDB"/>
+            </a:solidFill>
+            <a:prstDash val="solid"/>
+          </a:ln>
+        </p:spPr>
+      </p:sp>
+      <p:sp>
+        <p:nvSpPr>
+          <p:cNvPr id="7" name="Text 5"/>
+          <p:cNvSpPr txBox="1"/>
+          <p:nvPr/>
+        </p:nvSpPr>
+        <p:spPr>
+          <a:xfrm>
+            <a:off x="3406140" y="1344168"/>
+            <a:ext cx="2331720" cy="685800"/>
+          </a:xfrm>
+          <a:prstGeom prst="rect">
+            <a:avLst/>
+          </a:prstGeom>
+          <a:noFill/>
+          <a:ln/>
+        </p:spPr>
+        <p:txBody>
+          <a:bodyPr wrap="square" lIns="0" tIns="0" rIns="0" bIns="0" rtlCol="0" anchor="ctr"/>
+          <a:lstStyle/>
+          <a:p>
+            <a:pPr indent="0" marL="0">
+              <a:buNone/>
+            </a:pPr>
+            <a:r>
+              <a:rPr lang="en-US" sz="3000" b="1" dirty="0">
+                <a:solidFill>
+                  <a:schemeClr val="accent3"/>
+                </a:solidFill>
+                <a:latin typeface="+mj-lt" pitchFamily="34" charset="0"/>
+                <a:ea typeface="+mj-lt" pitchFamily="34" charset="-122"/>
+                <a:cs typeface="+mj-lt" pitchFamily="34" charset="-120"/>
+              </a:rPr>
+              <a:t>0</a:t>
+            </a:r>
+            <a:endParaRPr lang="en-US" sz="3000" dirty="0"/>
+          </a:p>
+        </p:txBody>
+      </p:sp>
+      <p:sp>
+        <p:nvSpPr>
+          <p:cNvPr id="8" name="Text 6"/>
+          <p:cNvSpPr txBox="1"/>
+          <p:nvPr/>
+        </p:nvSpPr>
+        <p:spPr>
+          <a:xfrm>
+            <a:off x="3406140" y="2057400"/>
+            <a:ext cx="2331720" cy="914400"/>
+          </a:xfrm>
+          <a:prstGeom prst="rect">
+            <a:avLst/>
+          </a:prstGeom>
+          <a:noFill/>
+          <a:ln/>
+        </p:spPr>
+        <p:txBody>
+          <a:bodyPr wrap="square" lIns="0" tIns="0" rIns="0" bIns="0" rtlCol="0" anchor="t"/>
+          <a:lstStyle/>
+          <a:p>
+            <a:pPr indent="0" marL="0">
+              <a:buNone/>
+            </a:pPr>
+            <a:r>
+              <a:rPr lang="en-US" sz="1200" dirty="0">
+                <a:solidFill>
+                  <a:schemeClr val="tx1"/>
+                </a:solidFill>
+              </a:rPr>
+              <a:t>Gaia sources within 12″</a:t>
+            </a:r>
+            <a:endParaRPr lang="en-US" sz="1200" dirty="0"/>
+          </a:p>
+        </p:txBody>
+      </p:sp>
+      <p:sp>
+        <p:nvSpPr>
+          <p:cNvPr id="9" name="card"/>
+          <p:cNvSpPr/>
+          <p:nvPr/>
+        </p:nvSpPr>
+        <p:spPr>
+          <a:xfrm>
+            <a:off x="6080760" y="1234440"/>
+            <a:ext cx="2606040" cy="1828800"/>
+          </a:xfrm>
+          <a:prstGeom prst="roundRect">
+            <a:avLst>
+              <a:gd name="adj" fmla="val 4000"/>
+            </a:avLst>
+          </a:prstGeom>
+          <a:solidFill>
+            <a:schemeClr val="bg1"/>
+          </a:solidFill>
+          <a:ln w="9525">
+            <a:solidFill>
+              <a:srgbClr val="C8CEDB"/>
+            </a:solidFill>
+            <a:prstDash val="solid"/>
+          </a:ln>
+        </p:spPr>
+      </p:sp>
+      <p:sp>
+        <p:nvSpPr>
+          <p:cNvPr id="10" name="Text 8"/>
+          <p:cNvSpPr txBox="1"/>
+          <p:nvPr/>
+        </p:nvSpPr>
+        <p:spPr>
+          <a:xfrm>
+            <a:off x="6217920" y="1344168"/>
+            <a:ext cx="2331720" cy="685800"/>
+          </a:xfrm>
+          <a:prstGeom prst="rect">
+            <a:avLst/>
+          </a:prstGeom>
+          <a:noFill/>
+          <a:ln/>
+        </p:spPr>
+        <p:txBody>
+          <a:bodyPr wrap="square" lIns="0" tIns="0" rIns="0" bIns="0" rtlCol="0" anchor="ctr"/>
+          <a:lstStyle/>
+          <a:p>
+            <a:pPr indent="0" marL="0">
+              <a:buNone/>
+            </a:pPr>
+            <a:r>
+              <a:rPr lang="en-US" sz="3000" b="1" dirty="0">
+                <a:solidFill>
+                  <a:schemeClr val="accent3"/>
+                </a:solidFill>
+                <a:latin typeface="+mj-lt" pitchFamily="34" charset="0"/>
+                <a:ea typeface="+mj-lt" pitchFamily="34" charset="-122"/>
+                <a:cs typeface="+mj-lt" pitchFamily="34" charset="-120"/>
+              </a:rPr>
+              <a:t>1.8%</a:t>
+            </a:r>
+            <a:endParaRPr lang="en-US" sz="3000" dirty="0"/>
+          </a:p>
+        </p:txBody>
+      </p:sp>
+      <p:sp>
+        <p:nvSpPr>
+          <p:cNvPr id="11" name="Text 9"/>
+          <p:cNvSpPr txBox="1"/>
+          <p:nvPr/>
+        </p:nvSpPr>
+        <p:spPr>
+          <a:xfrm>
+            <a:off x="6217920" y="2057400"/>
+            <a:ext cx="2331720" cy="914400"/>
+          </a:xfrm>
+          <a:prstGeom prst="rect">
+            <a:avLst/>
+          </a:prstGeom>
+          <a:noFill/>
+          <a:ln/>
+        </p:spPr>
+        <p:txBody>
+          <a:bodyPr wrap="square" lIns="0" tIns="0" rIns="0" bIns="0" rtlCol="0" anchor="t"/>
+          <a:lstStyle/>
+          <a:p>
+            <a:pPr indent="0" marL="0">
+              <a:buNone/>
+            </a:pPr>
+            <a:r>
+              <a:rPr lang="en-US" sz="1200" dirty="0">
+                <a:solidFill>
+                  <a:schemeClr val="tx1"/>
+                </a:solidFill>
+              </a:rPr>
+              <a:t>Flux from Gaia sources at 12–60″ (TESS dilution)</a:t>
+            </a:r>
+            <a:endParaRPr lang="en-US" sz="1200" dirty="0"/>
+          </a:p>
+        </p:txBody>
+      </p:sp>
+      <p:sp>
+        <p:nvSpPr>
+          <p:cNvPr id="25" name="Slide Number Placeholder 0"/>
+          <p:cNvSpPr>
+            <a:spLocks noGrp="1"/>
+          </p:cNvSpPr>
+          <p:nvPr>
+            <p:ph type="sldNum" sz="quarter" idx="4294967295"/>
+          </p:nvPr>
+        </p:nvSpPr>
+        <p:spPr>
+          <a:xfrm>
+            <a:off x="8412480" y="4800600"/>
+            <a:ext cx="457200" cy="228600"/>
+          </a:xfrm>
+          <a:prstGeom prst="rect">
+            <a:avLst/>
+          </a:prstGeom>
+          <a:extLst>
+            <a:ext uri="{C572A759-6A51-4108-AA02-DFA0A04FC94B}">
+              <ma14:wrappingTextBoxFlag xmlns:ma14="http://schemas.microsoft.com/office/mac/drawingml/2011/main" val="0"/>
+            </a:ext>
+          </a:extLst>
+        </p:spPr>
+        <p:txBody>
+          <a:bodyPr/>
+          <a:lstStyle>
+            <a:lvl1pPr>
+              <a:defRPr sz="900">
+                <a:solidFill>
+                  <a:srgbClr val="8A94A8"/>
+                </a:solidFill>
+              </a:defRPr>
+            </a:lvl1pPr>
+          </a:lstStyle>
+          <a:p>
+            <a:pPr algn="l"/>
+            <a:fld id="{F7021451-1387-4CA6-816F-3879F97B5CBC}" type="slidenum">
+              <a:rPr b="0" lang="en-US"/>
+              <a:t>9</a:t>
+            </a:fld>
+            <a:endParaRPr lang="en-US"/>
           </a:p>
         </p:txBody>
       </p:sp>

</xml_diff>